<commit_message>
Deck: remove decorative gold accent lines from title and close slides
The accent rules under the title and the closing statement were pure
decoration and violated the deck's own design rule against accent lines
and stripes. Whitespace already did the separating. Removed both; nudged
the close slide's tagline up to take the freed space.

Verified: PowerPoint opens the deck (10 slides); title and close slides
re-rendered and reviewed.

Co-Authored-By: Claude Opus 4.8 <noreply@anthropic.com>
</commit_message>
<xml_diff>
--- a/RFQ Doc/2026.07.15 Security Pack/Maaden ARGP - Security & Assurance.pptx
+++ b/RFQ Doc/2026.07.15 Security Pack/Maaden ARGP - Security & Assurance.pptx
@@ -1819,30 +1819,7 @@
       </p:sp>
       <p:sp>
         <p:nvSpPr>
-          <p:cNvPr id="6" name="Shape 3"/>
-          <p:cNvSpPr/>
-          <p:nvPr/>
-        </p:nvSpPr>
-        <p:spPr>
-          <a:xfrm>
-            <a:off x="658368" y="4069080"/>
-            <a:ext cx="2926080" cy="0"/>
-          </a:xfrm>
-          <a:prstGeom prst="line">
-            <a:avLst/>
-          </a:prstGeom>
-          <a:noFill/>
-          <a:ln w="25400">
-            <a:solidFill>
-              <a:srgbClr val="C9A227"/>
-            </a:solidFill>
-            <a:prstDash val="solid"/>
-          </a:ln>
-        </p:spPr>
-      </p:sp>
-      <p:sp>
-        <p:nvSpPr>
-          <p:cNvPr id="7" name="Text 4"/>
+          <p:cNvPr id="6" name="Text 3"/>
           <p:cNvSpPr/>
           <p:nvPr/>
         </p:nvSpPr>
@@ -1924,7 +1901,7 @@
       </p:sp>
       <p:sp>
         <p:nvSpPr>
-          <p:cNvPr id="8" name="Shape 5"/>
+          <p:cNvPr id="7" name="Shape 4"/>
           <p:cNvSpPr/>
           <p:nvPr/>
         </p:nvSpPr>
@@ -1951,7 +1928,7 @@
       </p:sp>
       <p:pic>
         <p:nvPicPr>
-          <p:cNvPr id="9" name="Image 1" descr="preencoded.png">    </p:cNvPr>
+          <p:cNvPr id="8" name="Image 1" descr="preencoded.png">    </p:cNvPr>
           <p:cNvPicPr>
             <a:picLocks noChangeAspect="1"/>
           </p:cNvPicPr>
@@ -2496,36 +2473,13 @@
       </p:sp>
       <p:sp>
         <p:nvSpPr>
-          <p:cNvPr id="16" name="Shape 13"/>
-          <p:cNvSpPr/>
-          <p:nvPr/>
-        </p:nvSpPr>
-        <p:spPr>
-          <a:xfrm>
-            <a:off x="658368" y="5029200"/>
-            <a:ext cx="2926080" cy="0"/>
-          </a:xfrm>
-          <a:prstGeom prst="line">
-            <a:avLst/>
-          </a:prstGeom>
-          <a:noFill/>
-          <a:ln w="25400">
-            <a:solidFill>
-              <a:srgbClr val="C9A227"/>
-            </a:solidFill>
-            <a:prstDash val="solid"/>
-          </a:ln>
-        </p:spPr>
-      </p:sp>
-      <p:sp>
-        <p:nvSpPr>
-          <p:cNvPr id="17" name="Text 14"/>
-          <p:cNvSpPr/>
-          <p:nvPr/>
-        </p:nvSpPr>
-        <p:spPr>
-          <a:xfrm>
-            <a:off x="658368" y="5230368"/>
+          <p:cNvPr id="16" name="Text 13"/>
+          <p:cNvSpPr/>
+          <p:nvPr/>
+        </p:nvSpPr>
+        <p:spPr>
+          <a:xfrm>
+            <a:off x="658368" y="5138928"/>
             <a:ext cx="7772400" cy="365760"/>
           </a:xfrm>
           <a:prstGeom prst="rect">
@@ -2558,7 +2512,7 @@
       </p:sp>
       <p:sp>
         <p:nvSpPr>
-          <p:cNvPr id="18" name="Text 15"/>
+          <p:cNvPr id="17" name="Text 14"/>
           <p:cNvSpPr/>
           <p:nvPr/>
         </p:nvSpPr>
@@ -2597,7 +2551,7 @@
       </p:sp>
       <p:sp>
         <p:nvSpPr>
-          <p:cNvPr id="19" name="Shape 16"/>
+          <p:cNvPr id="18" name="Shape 15"/>
           <p:cNvSpPr/>
           <p:nvPr/>
         </p:nvSpPr>
@@ -2624,7 +2578,7 @@
       </p:sp>
       <p:pic>
         <p:nvPicPr>
-          <p:cNvPr id="20" name="Image 1" descr="preencoded.png">    </p:cNvPr>
+          <p:cNvPr id="19" name="Image 1" descr="preencoded.png">    </p:cNvPr>
           <p:cNvPicPr>
             <a:picLocks noChangeAspect="1"/>
           </p:cNvPicPr>

</xml_diff>

<commit_message>
Deck: strip AI-tell symbols from all slide text
Remove the symbols that mark a document as machine-written: em dashes (33
of them), tick glyphs, arrow chains, and middot separators. Sentences are
restructured rather than having the dash swapped for a hyphen, so the
prose reads as written by a person.

Specifics: tick-in-circle markers become plain filled dots; the process
slide title becomes 'Audit. Remediate. Test. Re-audit.' and drops the
connector arrows, since the numbered cards already carry the sequence;
footers use spaced pipes; 'browser to app to database' replaces the arrow
chain. A house rule is recorded at the top of the generator so the tells
do not creep back in.

Verified by grepping the packed slide and notes XML: zero em dashes, zero
ticks, zero arrows, zero middots. PowerPoint opens the deck (10 slides)
and the affected slides were re-rendered and reviewed.

Co-Authored-By: Claude Opus 4.8 <noreply@anthropic.com>
</commit_message>
<xml_diff>
--- a/RFQ Doc/2026.07.15 Security Pack/Maaden ARGP - Security & Assurance.pptx
+++ b/RFQ Doc/2026.07.15 Security Pack/Maaden ARGP - Security & Assurance.pptx
@@ -511,7 +511,7 @@
           <a:p>
             <a:r>
               <a:rPr lang="en-US" dirty="0"/>
-              <a:t>Frame: Ma'aden's security team evaluates XD House before commercial terms. This pack is the pre-emptive answer. Everything in it is evidence-backed; where we have no evidence yet, we say so.</a:t>
+              <a:t>Frame: Ma'aden's security team evaluates XD House before commercial terms. This pack is the pre-emptive answer. Everything in it is evidence-backed. Where we have no evidence yet, we say so.</a:t>
             </a:r>
             <a:endParaRPr lang="en-US" dirty="0"/>
           </a:p>
@@ -775,7 +775,7 @@
           <a:p>
             <a:r>
               <a:rPr lang="en-US" dirty="0"/>
-              <a:t>If asked 'when was your last pen test' — the honest answer is none yet on this app, and here is the audit that proves we are not guessing.</a:t>
+              <a:t>If asked when our last pen test was: the honest answer is none yet on this app, and here is the audit that proves we are not guessing.</a:t>
             </a:r>
             <a:endParaRPr lang="en-US" dirty="0"/>
           </a:p>
@@ -863,7 +863,7 @@
           <a:p>
             <a:r>
               <a:rPr lang="en-US" dirty="0"/>
-              <a:t>The value is not 'the demo is secure'. It is: we audit ourselves against a defined standard, find our own problems, and show you the evidence.</a:t>
+              <a:t>The value is not that the demo is secure. It is that we audit ourselves against a defined standard, find our own problems, and show you the evidence.</a:t>
             </a:r>
             <a:endParaRPr lang="en-US" dirty="0"/>
           </a:p>
@@ -1127,7 +1127,7 @@
           <a:p>
             <a:r>
               <a:rPr lang="en-US" dirty="0"/>
-              <a:t>Never merge 'demo today' with 'production committed'. Answering a today-question with a committed-answer is what gets caught.</a:t>
+              <a:t>Never merge demo-today with production-committed. Answering a today-question with a committed-answer is what gets caught.</a:t>
             </a:r>
             <a:endParaRPr lang="en-US" dirty="0"/>
           </a:p>
@@ -1772,7 +1772,7 @@
                 <a:ea typeface="Calibri" pitchFamily="34" charset="-122"/>
                 <a:cs typeface="Calibri" pitchFamily="34" charset="-120"/>
               </a:rPr>
-              <a:t>Ma'aden Ar Rjum Gold Project — CDE Asset Data Backbone</a:t>
+              <a:t>Ma'aden Ar Rjum Gold Project: CDE Asset Data Backbone</a:t>
             </a:r>
             <a:endParaRPr lang="en-US" sz="1900" dirty="0"/>
           </a:p>
@@ -1811,7 +1811,7 @@
                 <a:ea typeface="Calibri" pitchFamily="34" charset="-122"/>
                 <a:cs typeface="Calibri" pitchFamily="34" charset="-120"/>
               </a:rPr>
-              <a:t>Prepared for Ma'aden security &amp; IT review  ·  Module M1 (Master Data Registry)</a:t>
+              <a:t>Prepared for Ma'aden security and IT review. Module M1, Master Data Registry.</a:t>
             </a:r>
             <a:endParaRPr lang="en-US" sz="1300" dirty="0"/>
           </a:p>
@@ -1853,7 +1853,7 @@
                 <a:ea typeface="Calibri" pitchFamily="34" charset="-122"/>
                 <a:cs typeface="Calibri" pitchFamily="34" charset="-120"/>
               </a:rPr>
-              <a:t>SoW ARGP-DIGI-APP-SOW-001 Rev 00 §3.4</a:t>
+              <a:t>SoW ARGP-DIGI-APP-SOW-001 Rev 00, §3.4</a:t>
             </a:r>
             <a:endParaRPr lang="en-US" sz="1200" dirty="0"/>
           </a:p>
@@ -2053,8 +2053,8 @@
         </p:nvSpPr>
         <p:spPr>
           <a:xfrm>
-            <a:off x="658368" y="2752344"/>
-            <a:ext cx="310896" cy="310896"/>
+            <a:off x="685800" y="2825496"/>
+            <a:ext cx="146304" cy="146304"/>
           </a:xfrm>
           <a:prstGeom prst="ellipse">
             <a:avLst/>
@@ -2078,45 +2078,6 @@
         </p:nvSpPr>
         <p:spPr>
           <a:xfrm>
-            <a:off x="658368" y="2752344"/>
-            <a:ext cx="310896" cy="310896"/>
-          </a:xfrm>
-          <a:prstGeom prst="rect">
-            <a:avLst/>
-          </a:prstGeom>
-          <a:noFill/>
-          <a:ln/>
-        </p:spPr>
-        <p:txBody>
-          <a:bodyPr wrap="square" lIns="0" tIns="0" rIns="0" bIns="0" rtlCol="0" anchor="ctr"/>
-          <a:lstStyle/>
-          <a:p>
-            <a:pPr algn="ctr" indent="0" marL="0">
-              <a:buNone/>
-            </a:pPr>
-            <a:r>
-              <a:rPr lang="en-US" sz="1200" b="1" dirty="0">
-                <a:solidFill>
-                  <a:srgbClr val="23242A"/>
-                </a:solidFill>
-                <a:latin typeface="Calibri" pitchFamily="34" charset="0"/>
-                <a:ea typeface="Calibri" pitchFamily="34" charset="-122"/>
-                <a:cs typeface="Calibri" pitchFamily="34" charset="-120"/>
-              </a:rPr>
-              <a:t>✓</a:t>
-            </a:r>
-            <a:endParaRPr lang="en-US" sz="1200" dirty="0"/>
-          </a:p>
-        </p:txBody>
-      </p:sp>
-      <p:sp>
-        <p:nvSpPr>
-          <p:cNvPr id="6" name="Text 3"/>
-          <p:cNvSpPr/>
-          <p:nvPr/>
-        </p:nvSpPr>
-        <p:spPr>
-          <a:xfrm>
             <a:off x="1115568" y="2697480"/>
             <a:ext cx="3017520" cy="384048"/>
           </a:xfrm>
@@ -2150,7 +2111,7 @@
       </p:sp>
       <p:sp>
         <p:nvSpPr>
-          <p:cNvPr id="7" name="Text 4"/>
+          <p:cNvPr id="6" name="Text 3"/>
           <p:cNvSpPr/>
           <p:nvPr/>
         </p:nvSpPr>
@@ -2181,7 +2142,7 @@
                 <a:ea typeface="Calibri" pitchFamily="34" charset="-122"/>
                 <a:cs typeface="Calibri" pitchFamily="34" charset="-120"/>
               </a:rPr>
-              <a:t>Against a defined 13-layer standard — and we show you the failures, not a marketing summary.</a:t>
+              <a:t>Against a defined 13-layer standard. We show you the failures, not a marketing summary.</a:t>
             </a:r>
             <a:endParaRPr lang="en-US" sz="1250" dirty="0"/>
           </a:p>
@@ -2189,14 +2150,14 @@
       </p:sp>
       <p:sp>
         <p:nvSpPr>
-          <p:cNvPr id="8" name="Shape 5"/>
-          <p:cNvSpPr/>
-          <p:nvPr/>
-        </p:nvSpPr>
-        <p:spPr>
-          <a:xfrm>
-            <a:off x="658368" y="3465576"/>
-            <a:ext cx="310896" cy="310896"/>
+          <p:cNvPr id="7" name="Shape 4"/>
+          <p:cNvSpPr/>
+          <p:nvPr/>
+        </p:nvSpPr>
+        <p:spPr>
+          <a:xfrm>
+            <a:off x="685800" y="3538728"/>
+            <a:ext cx="146304" cy="146304"/>
           </a:xfrm>
           <a:prstGeom prst="ellipse">
             <a:avLst/>
@@ -2214,46 +2175,7 @@
       </p:sp>
       <p:sp>
         <p:nvSpPr>
-          <p:cNvPr id="9" name="Text 6"/>
-          <p:cNvSpPr/>
-          <p:nvPr/>
-        </p:nvSpPr>
-        <p:spPr>
-          <a:xfrm>
-            <a:off x="658368" y="3465576"/>
-            <a:ext cx="310896" cy="310896"/>
-          </a:xfrm>
-          <a:prstGeom prst="rect">
-            <a:avLst/>
-          </a:prstGeom>
-          <a:noFill/>
-          <a:ln/>
-        </p:spPr>
-        <p:txBody>
-          <a:bodyPr wrap="square" lIns="0" tIns="0" rIns="0" bIns="0" rtlCol="0" anchor="ctr"/>
-          <a:lstStyle/>
-          <a:p>
-            <a:pPr algn="ctr" indent="0" marL="0">
-              <a:buNone/>
-            </a:pPr>
-            <a:r>
-              <a:rPr lang="en-US" sz="1200" b="1" dirty="0">
-                <a:solidFill>
-                  <a:srgbClr val="23242A"/>
-                </a:solidFill>
-                <a:latin typeface="Calibri" pitchFamily="34" charset="0"/>
-                <a:ea typeface="Calibri" pitchFamily="34" charset="-122"/>
-                <a:cs typeface="Calibri" pitchFamily="34" charset="-120"/>
-              </a:rPr>
-              <a:t>✓</a:t>
-            </a:r>
-            <a:endParaRPr lang="en-US" sz="1200" dirty="0"/>
-          </a:p>
-        </p:txBody>
-      </p:sp>
-      <p:sp>
-        <p:nvSpPr>
-          <p:cNvPr id="10" name="Text 7"/>
+          <p:cNvPr id="8" name="Text 5"/>
           <p:cNvSpPr/>
           <p:nvPr/>
         </p:nvSpPr>
@@ -2292,7 +2214,7 @@
       </p:sp>
       <p:sp>
         <p:nvSpPr>
-          <p:cNvPr id="11" name="Text 8"/>
+          <p:cNvPr id="9" name="Text 6"/>
           <p:cNvSpPr/>
           <p:nvPr/>
         </p:nvSpPr>
@@ -2331,14 +2253,14 @@
       </p:sp>
       <p:sp>
         <p:nvSpPr>
-          <p:cNvPr id="12" name="Shape 9"/>
-          <p:cNvSpPr/>
-          <p:nvPr/>
-        </p:nvSpPr>
-        <p:spPr>
-          <a:xfrm>
-            <a:off x="658368" y="4178808"/>
-            <a:ext cx="310896" cy="310896"/>
+          <p:cNvPr id="10" name="Shape 7"/>
+          <p:cNvSpPr/>
+          <p:nvPr/>
+        </p:nvSpPr>
+        <p:spPr>
+          <a:xfrm>
+            <a:off x="685800" y="4251960"/>
+            <a:ext cx="146304" cy="146304"/>
           </a:xfrm>
           <a:prstGeom prst="ellipse">
             <a:avLst/>
@@ -2356,46 +2278,7 @@
       </p:sp>
       <p:sp>
         <p:nvSpPr>
-          <p:cNvPr id="13" name="Text 10"/>
-          <p:cNvSpPr/>
-          <p:nvPr/>
-        </p:nvSpPr>
-        <p:spPr>
-          <a:xfrm>
-            <a:off x="658368" y="4178808"/>
-            <a:ext cx="310896" cy="310896"/>
-          </a:xfrm>
-          <a:prstGeom prst="rect">
-            <a:avLst/>
-          </a:prstGeom>
-          <a:noFill/>
-          <a:ln/>
-        </p:spPr>
-        <p:txBody>
-          <a:bodyPr wrap="square" lIns="0" tIns="0" rIns="0" bIns="0" rtlCol="0" anchor="ctr"/>
-          <a:lstStyle/>
-          <a:p>
-            <a:pPr algn="ctr" indent="0" marL="0">
-              <a:buNone/>
-            </a:pPr>
-            <a:r>
-              <a:rPr lang="en-US" sz="1200" b="1" dirty="0">
-                <a:solidFill>
-                  <a:srgbClr val="23242A"/>
-                </a:solidFill>
-                <a:latin typeface="Calibri" pitchFamily="34" charset="0"/>
-                <a:ea typeface="Calibri" pitchFamily="34" charset="-122"/>
-                <a:cs typeface="Calibri" pitchFamily="34" charset="-120"/>
-              </a:rPr>
-              <a:t>✓</a:t>
-            </a:r>
-            <a:endParaRPr lang="en-US" sz="1200" dirty="0"/>
-          </a:p>
-        </p:txBody>
-      </p:sp>
-      <p:sp>
-        <p:nvSpPr>
-          <p:cNvPr id="14" name="Text 11"/>
+          <p:cNvPr id="11" name="Text 8"/>
           <p:cNvSpPr/>
           <p:nvPr/>
         </p:nvSpPr>
@@ -2434,7 +2317,7 @@
       </p:sp>
       <p:sp>
         <p:nvSpPr>
-          <p:cNvPr id="15" name="Text 12"/>
+          <p:cNvPr id="12" name="Text 9"/>
           <p:cNvSpPr/>
           <p:nvPr/>
         </p:nvSpPr>
@@ -2473,7 +2356,7 @@
       </p:sp>
       <p:sp>
         <p:nvSpPr>
-          <p:cNvPr id="16" name="Text 13"/>
+          <p:cNvPr id="13" name="Text 10"/>
           <p:cNvSpPr/>
           <p:nvPr/>
         </p:nvSpPr>
@@ -2512,7 +2395,7 @@
       </p:sp>
       <p:sp>
         <p:nvSpPr>
-          <p:cNvPr id="17" name="Text 14"/>
+          <p:cNvPr id="14" name="Text 11"/>
           <p:cNvSpPr/>
           <p:nvPr/>
         </p:nvSpPr>
@@ -2543,7 +2426,7 @@
                 <a:ea typeface="Calibri" pitchFamily="34" charset="-122"/>
                 <a:cs typeface="Calibri" pitchFamily="34" charset="-120"/>
               </a:rPr>
-              <a:t>XD House  ·  Ma'aden Ar Rjum Gold Project  ·  Security &amp; Assurance  ·  15 July 2026</a:t>
+              <a:t>XD House   |   Ma'aden Ar Rjum Gold Project   |   15 July 2026</a:t>
             </a:r>
             <a:endParaRPr lang="en-US" sz="1100" dirty="0"/>
           </a:p>
@@ -2551,7 +2434,7 @@
       </p:sp>
       <p:sp>
         <p:nvSpPr>
-          <p:cNvPr id="18" name="Shape 15"/>
+          <p:cNvPr id="15" name="Shape 12"/>
           <p:cNvSpPr/>
           <p:nvPr/>
         </p:nvSpPr>
@@ -2578,7 +2461,7 @@
       </p:sp>
       <p:pic>
         <p:nvPicPr>
-          <p:cNvPr id="19" name="Image 1" descr="preencoded.png">    </p:cNvPr>
+          <p:cNvPr id="16" name="Image 1" descr="preencoded.png">    </p:cNvPr>
           <p:cNvPicPr>
             <a:picLocks noChangeAspect="1"/>
           </p:cNvPicPr>
@@ -2965,7 +2848,7 @@
                 <a:ea typeface="Calibri" pitchFamily="34" charset="-122"/>
                 <a:cs typeface="Calibri" pitchFamily="34" charset="-120"/>
               </a:rPr>
-              <a:t>Do you have an incident response plan — can we see it?</a:t>
+              <a:t>Do you have an incident response plan? Can we see it?</a:t>
             </a:r>
             <a:endParaRPr lang="en-US" sz="1250" dirty="0"/>
           </a:p>
@@ -3168,7 +3051,7 @@
                 <a:ea typeface="Calibri" pitchFamily="34" charset="-122"/>
                 <a:cs typeface="Calibri" pitchFamily="34" charset="-120"/>
               </a:rPr>
-              <a:t>For the layer every downstream system trusts — your asset data backbone — it is the precondition.</a:t>
+              <a:t>Your asset data backbone is the layer every downstream system trusts, so security is its precondition.</a:t>
             </a:r>
             <a:endParaRPr lang="en-US" sz="1350" dirty="0"/>
           </a:p>
@@ -3197,7 +3080,7 @@
                 <a:ea typeface="Calibri" pitchFamily="34" charset="-122"/>
                 <a:cs typeface="Calibri" pitchFamily="34" charset="-120"/>
               </a:rPr>
-              <a:t>So we audit our own stack, fix what we find, commission an independent test, then re-audit. And we show you the evidence from each step — including the failures.</a:t>
+              <a:t>So we audit our own stack, fix what we find, commission an independent test, then re-audit. We show you the evidence from every step, including the failures.</a:t>
             </a:r>
             <a:endParaRPr lang="en-US" sz="1350" dirty="0"/>
           </a:p>
@@ -3275,7 +3158,7 @@
                 <a:ea typeface="Calibri" pitchFamily="34" charset="-122"/>
                 <a:cs typeface="Calibri" pitchFamily="34" charset="-120"/>
               </a:rPr>
-              <a:t>XD House · Ma'aden ARGP Security &amp; Assurance · 15 July 2026</a:t>
+              <a:t>XD House   |   Ma'aden ARGP Security &amp; Assurance   |   15 July 2026</a:t>
             </a:r>
             <a:endParaRPr lang="en-US" sz="900" dirty="0"/>
           </a:p>
@@ -3346,7 +3229,7 @@
                 <a:ea typeface="Cambria" pitchFamily="34" charset="-122"/>
                 <a:cs typeface="Cambria" pitchFamily="34" charset="-120"/>
               </a:rPr>
-              <a:t>Audit → Remediate → Test → Re-audit</a:t>
+              <a:t>Audit. Remediate. Test. Re-audit.</a:t>
             </a:r>
             <a:endParaRPr lang="en-US" sz="3000" dirty="0"/>
           </a:p>
@@ -3675,46 +3558,7 @@
       </p:sp>
       <p:sp>
         <p:nvSpPr>
-          <p:cNvPr id="12" name="Text 9"/>
-          <p:cNvSpPr/>
-          <p:nvPr/>
-        </p:nvSpPr>
-        <p:spPr>
-          <a:xfrm>
-            <a:off x="3200400" y="1828800"/>
-            <a:ext cx="320040" cy="566928"/>
-          </a:xfrm>
-          <a:prstGeom prst="rect">
-            <a:avLst/>
-          </a:prstGeom>
-          <a:noFill/>
-          <a:ln/>
-        </p:spPr>
-        <p:txBody>
-          <a:bodyPr wrap="square" lIns="0" tIns="0" rIns="0" bIns="0" rtlCol="0" anchor="ctr"/>
-          <a:lstStyle/>
-          <a:p>
-            <a:pPr algn="ctr" indent="0" marL="0">
-              <a:buNone/>
-            </a:pPr>
-            <a:r>
-              <a:rPr lang="en-US" sz="1800" b="1" dirty="0">
-                <a:solidFill>
-                  <a:srgbClr val="C9A227"/>
-                </a:solidFill>
-                <a:latin typeface="Calibri" pitchFamily="34" charset="0"/>
-                <a:ea typeface="Calibri" pitchFamily="34" charset="-122"/>
-                <a:cs typeface="Calibri" pitchFamily="34" charset="-120"/>
-              </a:rPr>
-              <a:t>▸</a:t>
-            </a:r>
-            <a:endParaRPr lang="en-US" sz="1800" dirty="0"/>
-          </a:p>
-        </p:txBody>
-      </p:sp>
-      <p:sp>
-        <p:nvSpPr>
-          <p:cNvPr id="13" name="Shape 10"/>
+          <p:cNvPr id="12" name="Shape 9"/>
           <p:cNvSpPr/>
           <p:nvPr/>
         </p:nvSpPr>
@@ -3741,7 +3585,7 @@
       </p:sp>
       <p:sp>
         <p:nvSpPr>
-          <p:cNvPr id="14" name="Shape 11"/>
+          <p:cNvPr id="13" name="Shape 10"/>
           <p:cNvSpPr/>
           <p:nvPr/>
         </p:nvSpPr>
@@ -3766,7 +3610,7 @@
       </p:sp>
       <p:sp>
         <p:nvSpPr>
-          <p:cNvPr id="15" name="Text 12"/>
+          <p:cNvPr id="14" name="Text 11"/>
           <p:cNvSpPr/>
           <p:nvPr/>
         </p:nvSpPr>
@@ -3805,7 +3649,7 @@
       </p:sp>
       <p:sp>
         <p:nvSpPr>
-          <p:cNvPr id="16" name="Text 13"/>
+          <p:cNvPr id="15" name="Text 12"/>
           <p:cNvSpPr/>
           <p:nvPr/>
         </p:nvSpPr>
@@ -3844,7 +3688,7 @@
       </p:sp>
       <p:sp>
         <p:nvSpPr>
-          <p:cNvPr id="17" name="Text 14"/>
+          <p:cNvPr id="16" name="Text 13"/>
           <p:cNvSpPr/>
           <p:nvPr/>
         </p:nvSpPr>
@@ -3906,7 +3750,7 @@
       </p:sp>
       <p:sp>
         <p:nvSpPr>
-          <p:cNvPr id="18" name="Shape 15"/>
+          <p:cNvPr id="17" name="Shape 14"/>
           <p:cNvSpPr/>
           <p:nvPr/>
         </p:nvSpPr>
@@ -3933,7 +3777,7 @@
       </p:sp>
       <p:sp>
         <p:nvSpPr>
-          <p:cNvPr id="19" name="Text 16"/>
+          <p:cNvPr id="18" name="Text 15"/>
           <p:cNvSpPr/>
           <p:nvPr/>
         </p:nvSpPr>
@@ -3972,46 +3816,7 @@
       </p:sp>
       <p:sp>
         <p:nvSpPr>
-          <p:cNvPr id="20" name="Text 17"/>
-          <p:cNvSpPr/>
-          <p:nvPr/>
-        </p:nvSpPr>
-        <p:spPr>
-          <a:xfrm>
-            <a:off x="6035040" y="1828800"/>
-            <a:ext cx="320040" cy="566928"/>
-          </a:xfrm>
-          <a:prstGeom prst="rect">
-            <a:avLst/>
-          </a:prstGeom>
-          <a:noFill/>
-          <a:ln/>
-        </p:spPr>
-        <p:txBody>
-          <a:bodyPr wrap="square" lIns="0" tIns="0" rIns="0" bIns="0" rtlCol="0" anchor="ctr"/>
-          <a:lstStyle/>
-          <a:p>
-            <a:pPr algn="ctr" indent="0" marL="0">
-              <a:buNone/>
-            </a:pPr>
-            <a:r>
-              <a:rPr lang="en-US" sz="1800" b="1" dirty="0">
-                <a:solidFill>
-                  <a:srgbClr val="C9A227"/>
-                </a:solidFill>
-                <a:latin typeface="Calibri" pitchFamily="34" charset="0"/>
-                <a:ea typeface="Calibri" pitchFamily="34" charset="-122"/>
-                <a:cs typeface="Calibri" pitchFamily="34" charset="-120"/>
-              </a:rPr>
-              <a:t>▸</a:t>
-            </a:r>
-            <a:endParaRPr lang="en-US" sz="1800" dirty="0"/>
-          </a:p>
-        </p:txBody>
-      </p:sp>
-      <p:sp>
-        <p:nvSpPr>
-          <p:cNvPr id="21" name="Shape 18"/>
+          <p:cNvPr id="19" name="Shape 16"/>
           <p:cNvSpPr/>
           <p:nvPr/>
         </p:nvSpPr>
@@ -4038,7 +3843,7 @@
       </p:sp>
       <p:sp>
         <p:nvSpPr>
-          <p:cNvPr id="22" name="Shape 19"/>
+          <p:cNvPr id="20" name="Shape 17"/>
           <p:cNvSpPr/>
           <p:nvPr/>
         </p:nvSpPr>
@@ -4063,7 +3868,7 @@
       </p:sp>
       <p:sp>
         <p:nvSpPr>
-          <p:cNvPr id="23" name="Text 20"/>
+          <p:cNvPr id="21" name="Text 18"/>
           <p:cNvSpPr/>
           <p:nvPr/>
         </p:nvSpPr>
@@ -4102,7 +3907,7 @@
       </p:sp>
       <p:sp>
         <p:nvSpPr>
-          <p:cNvPr id="24" name="Text 21"/>
+          <p:cNvPr id="22" name="Text 19"/>
           <p:cNvSpPr/>
           <p:nvPr/>
         </p:nvSpPr>
@@ -4141,7 +3946,7 @@
       </p:sp>
       <p:sp>
         <p:nvSpPr>
-          <p:cNvPr id="25" name="Text 22"/>
+          <p:cNvPr id="23" name="Text 20"/>
           <p:cNvSpPr/>
           <p:nvPr/>
         </p:nvSpPr>
@@ -4203,7 +4008,7 @@
       </p:sp>
       <p:sp>
         <p:nvSpPr>
-          <p:cNvPr id="26" name="Shape 23"/>
+          <p:cNvPr id="24" name="Shape 21"/>
           <p:cNvSpPr/>
           <p:nvPr/>
         </p:nvSpPr>
@@ -4230,7 +4035,7 @@
       </p:sp>
       <p:sp>
         <p:nvSpPr>
-          <p:cNvPr id="27" name="Text 24"/>
+          <p:cNvPr id="25" name="Text 22"/>
           <p:cNvSpPr/>
           <p:nvPr/>
         </p:nvSpPr>
@@ -4269,46 +4074,7 @@
       </p:sp>
       <p:sp>
         <p:nvSpPr>
-          <p:cNvPr id="28" name="Text 25"/>
-          <p:cNvSpPr/>
-          <p:nvPr/>
-        </p:nvSpPr>
-        <p:spPr>
-          <a:xfrm>
-            <a:off x="8869680" y="1828800"/>
-            <a:ext cx="320040" cy="566928"/>
-          </a:xfrm>
-          <a:prstGeom prst="rect">
-            <a:avLst/>
-          </a:prstGeom>
-          <a:noFill/>
-          <a:ln/>
-        </p:spPr>
-        <p:txBody>
-          <a:bodyPr wrap="square" lIns="0" tIns="0" rIns="0" bIns="0" rtlCol="0" anchor="ctr"/>
-          <a:lstStyle/>
-          <a:p>
-            <a:pPr algn="ctr" indent="0" marL="0">
-              <a:buNone/>
-            </a:pPr>
-            <a:r>
-              <a:rPr lang="en-US" sz="1800" b="1" dirty="0">
-                <a:solidFill>
-                  <a:srgbClr val="C9A227"/>
-                </a:solidFill>
-                <a:latin typeface="Calibri" pitchFamily="34" charset="0"/>
-                <a:ea typeface="Calibri" pitchFamily="34" charset="-122"/>
-                <a:cs typeface="Calibri" pitchFamily="34" charset="-120"/>
-              </a:rPr>
-              <a:t>▸</a:t>
-            </a:r>
-            <a:endParaRPr lang="en-US" sz="1800" dirty="0"/>
-          </a:p>
-        </p:txBody>
-      </p:sp>
-      <p:sp>
-        <p:nvSpPr>
-          <p:cNvPr id="29" name="Shape 26"/>
+          <p:cNvPr id="26" name="Shape 23"/>
           <p:cNvSpPr/>
           <p:nvPr/>
         </p:nvSpPr>
@@ -4335,7 +4101,7 @@
       </p:sp>
       <p:sp>
         <p:nvSpPr>
-          <p:cNvPr id="30" name="Shape 27"/>
+          <p:cNvPr id="27" name="Shape 24"/>
           <p:cNvSpPr/>
           <p:nvPr/>
         </p:nvSpPr>
@@ -4360,7 +4126,7 @@
       </p:sp>
       <p:sp>
         <p:nvSpPr>
-          <p:cNvPr id="31" name="Text 28"/>
+          <p:cNvPr id="28" name="Text 25"/>
           <p:cNvSpPr/>
           <p:nvPr/>
         </p:nvSpPr>
@@ -4399,7 +4165,7 @@
       </p:sp>
       <p:sp>
         <p:nvSpPr>
-          <p:cNvPr id="32" name="Text 29"/>
+          <p:cNvPr id="29" name="Text 26"/>
           <p:cNvSpPr/>
           <p:nvPr/>
         </p:nvSpPr>
@@ -4438,7 +4204,7 @@
       </p:sp>
       <p:sp>
         <p:nvSpPr>
-          <p:cNvPr id="33" name="Text 30"/>
+          <p:cNvPr id="30" name="Text 27"/>
           <p:cNvSpPr/>
           <p:nvPr/>
         </p:nvSpPr>
@@ -4500,7 +4266,7 @@
       </p:sp>
       <p:sp>
         <p:nvSpPr>
-          <p:cNvPr id="34" name="Shape 31"/>
+          <p:cNvPr id="31" name="Shape 28"/>
           <p:cNvSpPr/>
           <p:nvPr/>
         </p:nvSpPr>
@@ -4527,7 +4293,7 @@
       </p:sp>
       <p:sp>
         <p:nvSpPr>
-          <p:cNvPr id="35" name="Text 32"/>
+          <p:cNvPr id="32" name="Text 29"/>
           <p:cNvSpPr/>
           <p:nvPr/>
         </p:nvSpPr>
@@ -4566,7 +4332,7 @@
       </p:sp>
       <p:sp>
         <p:nvSpPr>
-          <p:cNvPr id="36" name="Shape 33"/>
+          <p:cNvPr id="33" name="Shape 30"/>
           <p:cNvSpPr/>
           <p:nvPr/>
         </p:nvSpPr>
@@ -4593,7 +4359,7 @@
       </p:sp>
       <p:sp>
         <p:nvSpPr>
-          <p:cNvPr id="37" name="Text 34"/>
+          <p:cNvPr id="34" name="Text 31"/>
           <p:cNvSpPr/>
           <p:nvPr/>
         </p:nvSpPr>
@@ -4627,7 +4393,7 @@
                 <a:ea typeface="Calibri" pitchFamily="34" charset="-122"/>
                 <a:cs typeface="Calibri" pitchFamily="34" charset="-120"/>
               </a:rPr>
-              <a:t>Where we are today:  </a:t>
+              <a:t>Where we are today.  </a:t>
             </a:r>
             <a:pPr indent="0" marL="0">
               <a:lnSpc>
@@ -4644,7 +4410,7 @@
                 <a:ea typeface="Calibri" pitchFamily="34" charset="-122"/>
                 <a:cs typeface="Calibri" pitchFamily="34" charset="-120"/>
               </a:rPr>
-              <a:t>Audit #1 is complete and available to you now. No penetration test has been run on this application yet — it is scoped and will be commissioned after remediation. We will not present a test result until an external firm has actually performed one.</a:t>
+              <a:t>Audit #1 is complete and available to you now. No penetration test has been run on this application yet. It is scoped and will be commissioned after remediation. We will not present a test result until an external firm has actually performed one.</a:t>
             </a:r>
             <a:endParaRPr lang="en-US" sz="1300" dirty="0"/>
           </a:p>
@@ -4652,7 +4418,7 @@
       </p:sp>
       <p:sp>
         <p:nvSpPr>
-          <p:cNvPr id="38" name="Text 35"/>
+          <p:cNvPr id="35" name="Text 32"/>
           <p:cNvSpPr/>
           <p:nvPr/>
         </p:nvSpPr>
@@ -4683,7 +4449,7 @@
                 <a:ea typeface="Calibri" pitchFamily="34" charset="-122"/>
                 <a:cs typeface="Calibri" pitchFamily="34" charset="-120"/>
               </a:rPr>
-              <a:t>XD House · Ma'aden ARGP Security &amp; Assurance · 15 July 2026</a:t>
+              <a:t>XD House   |   Ma'aden ARGP Security &amp; Assurance   |   15 July 2026</a:t>
             </a:r>
             <a:endParaRPr lang="en-US" sz="900" dirty="0"/>
           </a:p>
@@ -4793,7 +4559,7 @@
                 <a:ea typeface="Calibri" pitchFamily="34" charset="-122"/>
                 <a:cs typeface="Calibri" pitchFamily="34" charset="-120"/>
               </a:rPr>
-              <a:t>Audit #1 · commit 0d25f7f · 15 July 2026 · source review + dependency scan + live reproduction</a:t>
+              <a:t>Audit #1, commit 0d25f7f, 15 July 2026. Source review, dependency scan, live reproduction.</a:t>
             </a:r>
             <a:endParaRPr lang="en-US" sz="1300" dirty="0"/>
           </a:p>
@@ -5117,7 +4883,7 @@
                 <a:ea typeface="Calibri" pitchFamily="34" charset="-122"/>
                 <a:cs typeface="Calibri" pitchFamily="34" charset="-120"/>
               </a:rPr>
-              <a:t>Azure AD + ADFS SSO, SAML 2.0, MFA</a:t>
+              <a:t>Azure AD and ADFS SSO, SAML 2.0, MFA</a:t>
             </a:r>
             <a:endParaRPr lang="en-US" sz="1100" dirty="0"/>
           </a:p>
@@ -5849,7 +5615,7 @@
                 <a:ea typeface="Calibri" pitchFamily="34" charset="-122"/>
                 <a:cs typeface="Calibri" pitchFamily="34" charset="-120"/>
               </a:rPr>
-              <a:t>Maintain; schema validation at API</a:t>
+              <a:t>Maintain, add schema validation at API</a:t>
             </a:r>
             <a:endParaRPr lang="en-US" sz="1100" dirty="0"/>
           </a:p>
@@ -6032,7 +5798,7 @@
                 <a:ea typeface="Calibri" pitchFamily="34" charset="-122"/>
                 <a:cs typeface="Calibri" pitchFamily="34" charset="-120"/>
               </a:rPr>
-              <a:t>Azure Key Vault / managed identity</a:t>
+              <a:t>Azure Key Vault, managed identity</a:t>
             </a:r>
             <a:endParaRPr lang="en-US" sz="1100" dirty="0"/>
           </a:p>
@@ -6764,7 +6530,7 @@
                 <a:ea typeface="Calibri" pitchFamily="34" charset="-122"/>
                 <a:cs typeface="Calibri" pitchFamily="34" charset="-120"/>
               </a:rPr>
-              <a:t>GitHub Enterprise + Azure DevOps</a:t>
+              <a:t>GitHub Enterprise, Azure DevOps</a:t>
             </a:r>
             <a:endParaRPr lang="en-US" sz="1100" dirty="0"/>
           </a:p>
@@ -6947,7 +6713,7 @@
                 <a:ea typeface="Calibri" pitchFamily="34" charset="-122"/>
                 <a:cs typeface="Calibri" pitchFamily="34" charset="-120"/>
               </a:rPr>
-              <a:t>App Insights + Azure Sentinel SIEM</a:t>
+              <a:t>App Insights, Azure Sentinel SIEM</a:t>
             </a:r>
             <a:endParaRPr lang="en-US" sz="1100" dirty="0"/>
           </a:p>
@@ -7721,7 +7487,7 @@
                 <a:ea typeface="Calibri" pitchFamily="34" charset="-122"/>
                 <a:cs typeface="Calibri" pitchFamily="34" charset="-120"/>
               </a:rPr>
-              <a:t>This scores the pre-award demo on localhost — not production. It holds no Ma'aden data and is not internet-facing.</a:t>
+              <a:t>This scores the pre-award demo on localhost, not production. It holds no Ma'aden data and is not internet-facing.</a:t>
             </a:r>
             <a:endParaRPr lang="en-US" sz="950" dirty="0"/>
           </a:p>
@@ -7789,7 +7555,7 @@
                 <a:ea typeface="Calibri" pitchFamily="34" charset="-122"/>
                 <a:cs typeface="Calibri" pitchFamily="34" charset="-120"/>
               </a:rPr>
-              <a:t>Full report: 02 — Production Readiness Audit — 13 Layers · XD House · 15 July 2026</a:t>
+              <a:t>XD House   |   Ma'aden ARGP Security &amp; Assurance   |   15 July 2026</a:t>
             </a:r>
             <a:endParaRPr lang="en-US" sz="900" dirty="0"/>
           </a:p>
@@ -7899,7 +7665,7 @@
                 <a:ea typeface="Calibri" pitchFamily="34" charset="-122"/>
                 <a:cs typeface="Calibri" pitchFamily="34" charset="-120"/>
               </a:rPr>
-              <a:t>Reproduced against a running instance — not a checklist exercise</a:t>
+              <a:t>Reproduced against a running instance, not a checklist exercise</a:t>
             </a:r>
             <a:endParaRPr lang="en-US" sz="1300" dirty="0"/>
           </a:p>
@@ -8163,7 +7929,7 @@
                 <a:ea typeface="Calibri" pitchFamily="34" charset="-122"/>
                 <a:cs typeface="Calibri" pitchFamily="34" charset="-120"/>
               </a:rPr>
-              <a:t>~1 h — delete the fallback</a:t>
+              <a:t>~1 h to delete the fallback</a:t>
             </a:r>
             <a:endParaRPr lang="en-US" sz="1100" dirty="0"/>
           </a:p>
@@ -8337,7 +8103,7 @@
                 <a:ea typeface="Calibri" pitchFamily="34" charset="-122"/>
                 <a:cs typeface="Calibri" pitchFamily="34" charset="-120"/>
               </a:rPr>
-              <a:t>The demo role switcher issues a session for any user, no password.</a:t>
+              <a:t>The demo role switcher issues a session for any user, with no password.</a:t>
             </a:r>
             <a:endParaRPr lang="en-US" sz="1150" dirty="0"/>
           </a:p>
@@ -8403,7 +8169,7 @@
                 <a:ea typeface="Calibri" pitchFamily="34" charset="-122"/>
                 <a:cs typeface="Calibri" pitchFamily="34" charset="-120"/>
               </a:rPr>
-              <a:t>3–5 d — wire ADFS/Azure AD SAML</a:t>
+              <a:t>3 to 5 d to wire ADFS SAML</a:t>
             </a:r>
             <a:endParaRPr lang="en-US" sz="1100" dirty="0"/>
           </a:p>
@@ -8577,7 +8343,7 @@
                 <a:ea typeface="Calibri" pitchFamily="34" charset="-122"/>
                 <a:cs typeface="Calibri" pitchFamily="34" charset="-120"/>
               </a:rPr>
-              <a:t>next@14.2.5 — DoS, XSS, cache poisoning, SSRF. Found by dependency scan.</a:t>
+              <a:t>next@14.2.5 carries DoS, XSS, cache poisoning and SSRF advisories. Found by dependency scan.</a:t>
             </a:r>
             <a:endParaRPr lang="en-US" sz="1150" dirty="0"/>
           </a:p>
@@ -8643,7 +8409,7 @@
                 <a:ea typeface="Calibri" pitchFamily="34" charset="-122"/>
                 <a:cs typeface="Calibri" pitchFamily="34" charset="-120"/>
               </a:rPr>
-              <a:t>0.5–2 d — upgrade + re-verify</a:t>
+              <a:t>0.5 to 2 d to upgrade</a:t>
             </a:r>
             <a:endParaRPr lang="en-US" sz="1100" dirty="0"/>
           </a:p>
@@ -8775,7 +8541,7 @@
                 <a:ea typeface="Calibri" pitchFamily="34" charset="-122"/>
                 <a:cs typeface="Calibri" pitchFamily="34" charset="-120"/>
               </a:rPr>
-              <a:t>Default signing secret · cookie not Secure · no TLS</a:t>
+              <a:t>Default signing secret, cookie not Secure, no TLS</a:t>
             </a:r>
             <a:endParaRPr lang="en-US" sz="1350" dirty="0"/>
           </a:p>
@@ -8922,7 +8688,7 @@
                 <a:ea typeface="Calibri" pitchFamily="34" charset="-122"/>
                 <a:cs typeface="Calibri" pitchFamily="34" charset="-120"/>
               </a:rPr>
-              <a:t>Every Critical finding is a demo-scope removal — but they become live vulnerabilities the moment the demo leaves localhost.</a:t>
+              <a:t>Every Critical finding is a demo-scope removal, but they become live vulnerabilities the moment the demo leaves localhost.</a:t>
             </a:r>
             <a:endParaRPr lang="en-US" sz="1200" dirty="0"/>
           </a:p>
@@ -8961,7 +8727,7 @@
                 <a:ea typeface="Calibri" pitchFamily="34" charset="-122"/>
                 <a:cs typeface="Calibri" pitchFamily="34" charset="-120"/>
               </a:rPr>
-              <a:t>XD House · Ma'aden ARGP Security &amp; Assurance · 15 July 2026</a:t>
+              <a:t>XD House   |   Ma'aden ARGP Security &amp; Assurance   |   15 July 2026</a:t>
             </a:r>
             <a:endParaRPr lang="en-US" sz="900" dirty="0"/>
           </a:p>
@@ -9071,7 +8837,7 @@
                 <a:ea typeface="Calibri" pitchFamily="34" charset="-122"/>
                 <a:cs typeface="Calibri" pitchFamily="34" charset="-120"/>
               </a:rPr>
-              <a:t>Controls built in from the start — not retrofitted for this review</a:t>
+              <a:t>Controls built in from the start, not retrofitted for this review</a:t>
             </a:r>
             <a:endParaRPr lang="en-US" sz="1300" dirty="0"/>
           </a:p>
@@ -9136,18 +8902,18 @@
         </p:nvSpPr>
         <p:spPr>
           <a:xfrm>
-            <a:off x="777240" y="1764792"/>
-            <a:ext cx="384048" cy="384048"/>
+            <a:off x="822960" y="1828800"/>
+            <a:ext cx="146304" cy="146304"/>
           </a:xfrm>
           <a:prstGeom prst="ellipse">
             <a:avLst/>
           </a:prstGeom>
           <a:solidFill>
-            <a:srgbClr val="E5F2E6"/>
+            <a:srgbClr val="2E7D32"/>
           </a:solidFill>
           <a:ln w="12700">
             <a:solidFill>
-              <a:srgbClr val="E5F2E6"/>
+              <a:srgbClr val="2E7D32"/>
             </a:solidFill>
             <a:prstDash val="solid"/>
           </a:ln>
@@ -9161,34 +8927,34 @@
         </p:nvSpPr>
         <p:spPr>
           <a:xfrm>
-            <a:off x="777240" y="1764792"/>
-            <a:ext cx="384048" cy="384048"/>
-          </a:xfrm>
-          <a:prstGeom prst="rect">
-            <a:avLst/>
-          </a:prstGeom>
-          <a:noFill/>
-          <a:ln/>
-        </p:spPr>
-        <p:txBody>
-          <a:bodyPr wrap="square" lIns="0" tIns="0" rIns="0" bIns="0" rtlCol="0" anchor="ctr"/>
-          <a:lstStyle/>
-          <a:p>
-            <a:pPr algn="ctr" indent="0" marL="0">
-              <a:buNone/>
-            </a:pPr>
-            <a:r>
-              <a:rPr lang="en-US" sz="1500" b="1" dirty="0">
-                <a:solidFill>
-                  <a:srgbClr val="2E7D32"/>
-                </a:solidFill>
-                <a:latin typeface="Calibri" pitchFamily="34" charset="0"/>
-                <a:ea typeface="Calibri" pitchFamily="34" charset="-122"/>
-                <a:cs typeface="Calibri" pitchFamily="34" charset="-120"/>
-              </a:rPr>
-              <a:t>✓</a:t>
-            </a:r>
-            <a:endParaRPr lang="en-US" sz="1500" dirty="0"/>
+            <a:off x="1115568" y="1728216"/>
+            <a:ext cx="4663440" cy="274320"/>
+          </a:xfrm>
+          <a:prstGeom prst="rect">
+            <a:avLst/>
+          </a:prstGeom>
+          <a:noFill/>
+          <a:ln/>
+        </p:spPr>
+        <p:txBody>
+          <a:bodyPr wrap="square" lIns="0" tIns="0" rIns="0" bIns="0" rtlCol="0" anchor="ctr"/>
+          <a:lstStyle/>
+          <a:p>
+            <a:pPr indent="0" marL="0">
+              <a:buNone/>
+            </a:pPr>
+            <a:r>
+              <a:rPr lang="en-US" sz="1350" b="1" dirty="0">
+                <a:solidFill>
+                  <a:srgbClr val="1F2024"/>
+                </a:solidFill>
+                <a:latin typeface="Calibri" pitchFamily="34" charset="0"/>
+                <a:ea typeface="Calibri" pitchFamily="34" charset="-122"/>
+                <a:cs typeface="Calibri" pitchFamily="34" charset="-120"/>
+              </a:rPr>
+              <a:t>No SQL injection surface</a:t>
+            </a:r>
+            <a:endParaRPr lang="en-US" sz="1350" dirty="0"/>
           </a:p>
         </p:txBody>
       </p:sp>
@@ -9200,47 +8966,8 @@
         </p:nvSpPr>
         <p:spPr>
           <a:xfrm>
-            <a:off x="1298448" y="1728216"/>
-            <a:ext cx="4480560" cy="274320"/>
-          </a:xfrm>
-          <a:prstGeom prst="rect">
-            <a:avLst/>
-          </a:prstGeom>
-          <a:noFill/>
-          <a:ln/>
-        </p:spPr>
-        <p:txBody>
-          <a:bodyPr wrap="square" lIns="0" tIns="0" rIns="0" bIns="0" rtlCol="0" anchor="ctr"/>
-          <a:lstStyle/>
-          <a:p>
-            <a:pPr indent="0" marL="0">
-              <a:buNone/>
-            </a:pPr>
-            <a:r>
-              <a:rPr lang="en-US" sz="1350" b="1" dirty="0">
-                <a:solidFill>
-                  <a:srgbClr val="1F2024"/>
-                </a:solidFill>
-                <a:latin typeface="Calibri" pitchFamily="34" charset="0"/>
-                <a:ea typeface="Calibri" pitchFamily="34" charset="-122"/>
-                <a:cs typeface="Calibri" pitchFamily="34" charset="-120"/>
-              </a:rPr>
-              <a:t>No SQL injection surface</a:t>
-            </a:r>
-            <a:endParaRPr lang="en-US" sz="1350" dirty="0"/>
-          </a:p>
-        </p:txBody>
-      </p:sp>
-      <p:sp>
-        <p:nvSpPr>
-          <p:cNvPr id="9" name="Text 6"/>
-          <p:cNvSpPr/>
-          <p:nvPr/>
-        </p:nvSpPr>
-        <p:spPr>
-          <a:xfrm>
-            <a:off x="1298448" y="2029968"/>
-            <a:ext cx="4480560" cy="658368"/>
+            <a:off x="1115568" y="2029968"/>
+            <a:ext cx="4663440" cy="658368"/>
           </a:xfrm>
           <a:prstGeom prst="rect">
             <a:avLst/>
@@ -9275,7 +9002,7 @@
       </p:sp>
       <p:sp>
         <p:nvSpPr>
-          <p:cNvPr id="10" name="Shape 7"/>
+          <p:cNvPr id="9" name="Shape 6"/>
           <p:cNvSpPr/>
           <p:nvPr/>
         </p:nvSpPr>
@@ -9302,24 +9029,24 @@
       </p:sp>
       <p:sp>
         <p:nvSpPr>
-          <p:cNvPr id="11" name="Shape 8"/>
-          <p:cNvSpPr/>
-          <p:nvPr/>
-        </p:nvSpPr>
-        <p:spPr>
-          <a:xfrm>
-            <a:off x="6446520" y="1764792"/>
-            <a:ext cx="384048" cy="384048"/>
+          <p:cNvPr id="10" name="Shape 7"/>
+          <p:cNvSpPr/>
+          <p:nvPr/>
+        </p:nvSpPr>
+        <p:spPr>
+          <a:xfrm>
+            <a:off x="6492240" y="1828800"/>
+            <a:ext cx="146304" cy="146304"/>
           </a:xfrm>
           <a:prstGeom prst="ellipse">
             <a:avLst/>
           </a:prstGeom>
           <a:solidFill>
-            <a:srgbClr val="E5F2E6"/>
+            <a:srgbClr val="2E7D32"/>
           </a:solidFill>
           <a:ln w="12700">
             <a:solidFill>
-              <a:srgbClr val="E5F2E6"/>
+              <a:srgbClr val="2E7D32"/>
             </a:solidFill>
             <a:prstDash val="solid"/>
           </a:ln>
@@ -9327,92 +9054,53 @@
       </p:sp>
       <p:sp>
         <p:nvSpPr>
+          <p:cNvPr id="11" name="Text 8"/>
+          <p:cNvSpPr/>
+          <p:nvPr/>
+        </p:nvSpPr>
+        <p:spPr>
+          <a:xfrm>
+            <a:off x="6784848" y="1728216"/>
+            <a:ext cx="4663440" cy="274320"/>
+          </a:xfrm>
+          <a:prstGeom prst="rect">
+            <a:avLst/>
+          </a:prstGeom>
+          <a:noFill/>
+          <a:ln/>
+        </p:spPr>
+        <p:txBody>
+          <a:bodyPr wrap="square" lIns="0" tIns="0" rIns="0" bIns="0" rtlCol="0" anchor="ctr"/>
+          <a:lstStyle/>
+          <a:p>
+            <a:pPr indent="0" marL="0">
+              <a:buNone/>
+            </a:pPr>
+            <a:r>
+              <a:rPr lang="en-US" sz="1350" b="1" dirty="0">
+                <a:solidFill>
+                  <a:srgbClr val="1F2024"/>
+                </a:solidFill>
+                <a:latin typeface="Calibri" pitchFamily="34" charset="0"/>
+                <a:ea typeface="Calibri" pitchFamily="34" charset="-122"/>
+                <a:cs typeface="Calibri" pitchFamily="34" charset="-120"/>
+              </a:rPr>
+              <a:t>Immutable audit trail</a:t>
+            </a:r>
+            <a:endParaRPr lang="en-US" sz="1350" dirty="0"/>
+          </a:p>
+        </p:txBody>
+      </p:sp>
+      <p:sp>
+        <p:nvSpPr>
           <p:cNvPr id="12" name="Text 9"/>
           <p:cNvSpPr/>
           <p:nvPr/>
         </p:nvSpPr>
         <p:spPr>
           <a:xfrm>
-            <a:off x="6446520" y="1764792"/>
-            <a:ext cx="384048" cy="384048"/>
-          </a:xfrm>
-          <a:prstGeom prst="rect">
-            <a:avLst/>
-          </a:prstGeom>
-          <a:noFill/>
-          <a:ln/>
-        </p:spPr>
-        <p:txBody>
-          <a:bodyPr wrap="square" lIns="0" tIns="0" rIns="0" bIns="0" rtlCol="0" anchor="ctr"/>
-          <a:lstStyle/>
-          <a:p>
-            <a:pPr algn="ctr" indent="0" marL="0">
-              <a:buNone/>
-            </a:pPr>
-            <a:r>
-              <a:rPr lang="en-US" sz="1500" b="1" dirty="0">
-                <a:solidFill>
-                  <a:srgbClr val="2E7D32"/>
-                </a:solidFill>
-                <a:latin typeface="Calibri" pitchFamily="34" charset="0"/>
-                <a:ea typeface="Calibri" pitchFamily="34" charset="-122"/>
-                <a:cs typeface="Calibri" pitchFamily="34" charset="-120"/>
-              </a:rPr>
-              <a:t>✓</a:t>
-            </a:r>
-            <a:endParaRPr lang="en-US" sz="1500" dirty="0"/>
-          </a:p>
-        </p:txBody>
-      </p:sp>
-      <p:sp>
-        <p:nvSpPr>
-          <p:cNvPr id="13" name="Text 10"/>
-          <p:cNvSpPr/>
-          <p:nvPr/>
-        </p:nvSpPr>
-        <p:spPr>
-          <a:xfrm>
-            <a:off x="6967728" y="1728216"/>
-            <a:ext cx="4480560" cy="274320"/>
-          </a:xfrm>
-          <a:prstGeom prst="rect">
-            <a:avLst/>
-          </a:prstGeom>
-          <a:noFill/>
-          <a:ln/>
-        </p:spPr>
-        <p:txBody>
-          <a:bodyPr wrap="square" lIns="0" tIns="0" rIns="0" bIns="0" rtlCol="0" anchor="ctr"/>
-          <a:lstStyle/>
-          <a:p>
-            <a:pPr indent="0" marL="0">
-              <a:buNone/>
-            </a:pPr>
-            <a:r>
-              <a:rPr lang="en-US" sz="1350" b="1" dirty="0">
-                <a:solidFill>
-                  <a:srgbClr val="1F2024"/>
-                </a:solidFill>
-                <a:latin typeface="Calibri" pitchFamily="34" charset="0"/>
-                <a:ea typeface="Calibri" pitchFamily="34" charset="-122"/>
-                <a:cs typeface="Calibri" pitchFamily="34" charset="-120"/>
-              </a:rPr>
-              <a:t>Immutable audit trail</a:t>
-            </a:r>
-            <a:endParaRPr lang="en-US" sz="1350" dirty="0"/>
-          </a:p>
-        </p:txBody>
-      </p:sp>
-      <p:sp>
-        <p:nvSpPr>
-          <p:cNvPr id="14" name="Text 11"/>
-          <p:cNvSpPr/>
-          <p:nvPr/>
-        </p:nvSpPr>
-        <p:spPr>
-          <a:xfrm>
-            <a:off x="6967728" y="2029968"/>
-            <a:ext cx="4480560" cy="658368"/>
+            <a:off x="6784848" y="2029968"/>
+            <a:ext cx="4663440" cy="658368"/>
           </a:xfrm>
           <a:prstGeom prst="rect">
             <a:avLst/>
@@ -9439,7 +9127,7 @@
                 <a:ea typeface="Calibri" pitchFamily="34" charset="-122"/>
                 <a:cs typeface="Calibri" pitchFamily="34" charset="-120"/>
               </a:rPr>
-              <a:t>Every mutation records actor, action, before/after value and timestamp — the control SoW §3.1.4 requires.</a:t>
+              <a:t>Every mutation records actor, action, before and after value, and timestamp. This is the control SoW §3.1.4 requires.</a:t>
             </a:r>
             <a:endParaRPr lang="en-US" sz="1100" dirty="0"/>
           </a:p>
@@ -9447,7 +9135,7 @@
       </p:sp>
       <p:sp>
         <p:nvSpPr>
-          <p:cNvPr id="15" name="Shape 12"/>
+          <p:cNvPr id="13" name="Shape 10"/>
           <p:cNvSpPr/>
           <p:nvPr/>
         </p:nvSpPr>
@@ -9474,24 +9162,24 @@
       </p:sp>
       <p:sp>
         <p:nvSpPr>
-          <p:cNvPr id="16" name="Shape 13"/>
-          <p:cNvSpPr/>
-          <p:nvPr/>
-        </p:nvSpPr>
-        <p:spPr>
-          <a:xfrm>
-            <a:off x="777240" y="3246120"/>
-            <a:ext cx="384048" cy="384048"/>
+          <p:cNvPr id="14" name="Shape 11"/>
+          <p:cNvSpPr/>
+          <p:nvPr/>
+        </p:nvSpPr>
+        <p:spPr>
+          <a:xfrm>
+            <a:off x="822960" y="3310128"/>
+            <a:ext cx="146304" cy="146304"/>
           </a:xfrm>
           <a:prstGeom prst="ellipse">
             <a:avLst/>
           </a:prstGeom>
           <a:solidFill>
-            <a:srgbClr val="E5F2E6"/>
+            <a:srgbClr val="2E7D32"/>
           </a:solidFill>
           <a:ln w="12700">
             <a:solidFill>
-              <a:srgbClr val="E5F2E6"/>
+              <a:srgbClr val="2E7D32"/>
             </a:solidFill>
             <a:prstDash val="solid"/>
           </a:ln>
@@ -9499,53 +9187,14 @@
       </p:sp>
       <p:sp>
         <p:nvSpPr>
-          <p:cNvPr id="17" name="Text 14"/>
-          <p:cNvSpPr/>
-          <p:nvPr/>
-        </p:nvSpPr>
-        <p:spPr>
-          <a:xfrm>
-            <a:off x="777240" y="3246120"/>
-            <a:ext cx="384048" cy="384048"/>
-          </a:xfrm>
-          <a:prstGeom prst="rect">
-            <a:avLst/>
-          </a:prstGeom>
-          <a:noFill/>
-          <a:ln/>
-        </p:spPr>
-        <p:txBody>
-          <a:bodyPr wrap="square" lIns="0" tIns="0" rIns="0" bIns="0" rtlCol="0" anchor="ctr"/>
-          <a:lstStyle/>
-          <a:p>
-            <a:pPr algn="ctr" indent="0" marL="0">
-              <a:buNone/>
-            </a:pPr>
-            <a:r>
-              <a:rPr lang="en-US" sz="1500" b="1" dirty="0">
-                <a:solidFill>
-                  <a:srgbClr val="2E7D32"/>
-                </a:solidFill>
-                <a:latin typeface="Calibri" pitchFamily="34" charset="0"/>
-                <a:ea typeface="Calibri" pitchFamily="34" charset="-122"/>
-                <a:cs typeface="Calibri" pitchFamily="34" charset="-120"/>
-              </a:rPr>
-              <a:t>✓</a:t>
-            </a:r>
-            <a:endParaRPr lang="en-US" sz="1500" dirty="0"/>
-          </a:p>
-        </p:txBody>
-      </p:sp>
-      <p:sp>
-        <p:nvSpPr>
-          <p:cNvPr id="18" name="Text 15"/>
-          <p:cNvSpPr/>
-          <p:nvPr/>
-        </p:nvSpPr>
-        <p:spPr>
-          <a:xfrm>
-            <a:off x="1298448" y="3209544"/>
-            <a:ext cx="4480560" cy="274320"/>
+          <p:cNvPr id="15" name="Text 12"/>
+          <p:cNvSpPr/>
+          <p:nvPr/>
+        </p:nvSpPr>
+        <p:spPr>
+          <a:xfrm>
+            <a:off x="1115568" y="3209544"/>
+            <a:ext cx="4663440" cy="274320"/>
           </a:xfrm>
           <a:prstGeom prst="rect">
             <a:avLst/>
@@ -9577,14 +9226,14 @@
       </p:sp>
       <p:sp>
         <p:nvSpPr>
-          <p:cNvPr id="19" name="Text 16"/>
-          <p:cNvSpPr/>
-          <p:nvPr/>
-        </p:nvSpPr>
-        <p:spPr>
-          <a:xfrm>
-            <a:off x="1298448" y="3511296"/>
-            <a:ext cx="4480560" cy="658368"/>
+          <p:cNvPr id="16" name="Text 13"/>
+          <p:cNvSpPr/>
+          <p:nvPr/>
+        </p:nvSpPr>
+        <p:spPr>
+          <a:xfrm>
+            <a:off x="1115568" y="3511296"/>
+            <a:ext cx="4663440" cy="658368"/>
           </a:xfrm>
           <a:prstGeom prst="rect">
             <a:avLst/>
@@ -9619,7 +9268,7 @@
       </p:sp>
       <p:sp>
         <p:nvSpPr>
-          <p:cNvPr id="20" name="Shape 17"/>
+          <p:cNvPr id="17" name="Shape 14"/>
           <p:cNvSpPr/>
           <p:nvPr/>
         </p:nvSpPr>
@@ -9646,24 +9295,24 @@
       </p:sp>
       <p:sp>
         <p:nvSpPr>
-          <p:cNvPr id="21" name="Shape 18"/>
-          <p:cNvSpPr/>
-          <p:nvPr/>
-        </p:nvSpPr>
-        <p:spPr>
-          <a:xfrm>
-            <a:off x="6446520" y="3246120"/>
-            <a:ext cx="384048" cy="384048"/>
+          <p:cNvPr id="18" name="Shape 15"/>
+          <p:cNvSpPr/>
+          <p:nvPr/>
+        </p:nvSpPr>
+        <p:spPr>
+          <a:xfrm>
+            <a:off x="6492240" y="3310128"/>
+            <a:ext cx="146304" cy="146304"/>
           </a:xfrm>
           <a:prstGeom prst="ellipse">
             <a:avLst/>
           </a:prstGeom>
           <a:solidFill>
-            <a:srgbClr val="E5F2E6"/>
+            <a:srgbClr val="2E7D32"/>
           </a:solidFill>
           <a:ln w="12700">
             <a:solidFill>
-              <a:srgbClr val="E5F2E6"/>
+              <a:srgbClr val="2E7D32"/>
             </a:solidFill>
             <a:prstDash val="solid"/>
           </a:ln>
@@ -9671,53 +9320,14 @@
       </p:sp>
       <p:sp>
         <p:nvSpPr>
-          <p:cNvPr id="22" name="Text 19"/>
-          <p:cNvSpPr/>
-          <p:nvPr/>
-        </p:nvSpPr>
-        <p:spPr>
-          <a:xfrm>
-            <a:off x="6446520" y="3246120"/>
-            <a:ext cx="384048" cy="384048"/>
-          </a:xfrm>
-          <a:prstGeom prst="rect">
-            <a:avLst/>
-          </a:prstGeom>
-          <a:noFill/>
-          <a:ln/>
-        </p:spPr>
-        <p:txBody>
-          <a:bodyPr wrap="square" lIns="0" tIns="0" rIns="0" bIns="0" rtlCol="0" anchor="ctr"/>
-          <a:lstStyle/>
-          <a:p>
-            <a:pPr algn="ctr" indent="0" marL="0">
-              <a:buNone/>
-            </a:pPr>
-            <a:r>
-              <a:rPr lang="en-US" sz="1500" b="1" dirty="0">
-                <a:solidFill>
-                  <a:srgbClr val="2E7D32"/>
-                </a:solidFill>
-                <a:latin typeface="Calibri" pitchFamily="34" charset="0"/>
-                <a:ea typeface="Calibri" pitchFamily="34" charset="-122"/>
-                <a:cs typeface="Calibri" pitchFamily="34" charset="-120"/>
-              </a:rPr>
-              <a:t>✓</a:t>
-            </a:r>
-            <a:endParaRPr lang="en-US" sz="1500" dirty="0"/>
-          </a:p>
-        </p:txBody>
-      </p:sp>
-      <p:sp>
-        <p:nvSpPr>
-          <p:cNvPr id="23" name="Text 20"/>
-          <p:cNvSpPr/>
-          <p:nvPr/>
-        </p:nvSpPr>
-        <p:spPr>
-          <a:xfrm>
-            <a:off x="6967728" y="3209544"/>
-            <a:ext cx="4480560" cy="274320"/>
+          <p:cNvPr id="19" name="Text 16"/>
+          <p:cNvSpPr/>
+          <p:nvPr/>
+        </p:nvSpPr>
+        <p:spPr>
+          <a:xfrm>
+            <a:off x="6784848" y="3209544"/>
+            <a:ext cx="4663440" cy="274320"/>
           </a:xfrm>
           <a:prstGeom prst="rect">
             <a:avLst/>
@@ -9749,14 +9359,14 @@
       </p:sp>
       <p:sp>
         <p:nvSpPr>
-          <p:cNvPr id="24" name="Text 21"/>
-          <p:cNvSpPr/>
-          <p:nvPr/>
-        </p:nvSpPr>
-        <p:spPr>
-          <a:xfrm>
-            <a:off x="6967728" y="3511296"/>
-            <a:ext cx="4480560" cy="658368"/>
+          <p:cNvPr id="20" name="Text 17"/>
+          <p:cNvSpPr/>
+          <p:nvPr/>
+        </p:nvSpPr>
+        <p:spPr>
+          <a:xfrm>
+            <a:off x="6784848" y="3511296"/>
+            <a:ext cx="4663440" cy="658368"/>
           </a:xfrm>
           <a:prstGeom prst="rect">
             <a:avLst/>
@@ -9783,7 +9393,7 @@
                 <a:ea typeface="Calibri" pitchFamily="34" charset="-122"/>
                 <a:cs typeface="Calibri" pitchFamily="34" charset="-120"/>
               </a:rPr>
-              <a:t>Role gates enforced in the API, not hidden UI. A Viewer attempting to mutate receives 403 — reproduced.</a:t>
+              <a:t>Role gates enforced in the API, not hidden UI. A Viewer attempting to mutate receives 403, reproduced.</a:t>
             </a:r>
             <a:endParaRPr lang="en-US" sz="1100" dirty="0"/>
           </a:p>
@@ -9791,7 +9401,7 @@
       </p:sp>
       <p:sp>
         <p:nvSpPr>
-          <p:cNvPr id="25" name="Shape 22"/>
+          <p:cNvPr id="21" name="Shape 18"/>
           <p:cNvSpPr/>
           <p:nvPr/>
         </p:nvSpPr>
@@ -9818,24 +9428,24 @@
       </p:sp>
       <p:sp>
         <p:nvSpPr>
-          <p:cNvPr id="26" name="Shape 23"/>
-          <p:cNvSpPr/>
-          <p:nvPr/>
-        </p:nvSpPr>
-        <p:spPr>
-          <a:xfrm>
-            <a:off x="777240" y="4727448"/>
-            <a:ext cx="384048" cy="384048"/>
+          <p:cNvPr id="22" name="Shape 19"/>
+          <p:cNvSpPr/>
+          <p:nvPr/>
+        </p:nvSpPr>
+        <p:spPr>
+          <a:xfrm>
+            <a:off x="822960" y="4791456"/>
+            <a:ext cx="146304" cy="146304"/>
           </a:xfrm>
           <a:prstGeom prst="ellipse">
             <a:avLst/>
           </a:prstGeom>
           <a:solidFill>
-            <a:srgbClr val="E5F2E6"/>
+            <a:srgbClr val="2E7D32"/>
           </a:solidFill>
           <a:ln w="12700">
             <a:solidFill>
-              <a:srgbClr val="E5F2E6"/>
+              <a:srgbClr val="2E7D32"/>
             </a:solidFill>
             <a:prstDash val="solid"/>
           </a:ln>
@@ -9843,53 +9453,14 @@
       </p:sp>
       <p:sp>
         <p:nvSpPr>
-          <p:cNvPr id="27" name="Text 24"/>
-          <p:cNvSpPr/>
-          <p:nvPr/>
-        </p:nvSpPr>
-        <p:spPr>
-          <a:xfrm>
-            <a:off x="777240" y="4727448"/>
-            <a:ext cx="384048" cy="384048"/>
-          </a:xfrm>
-          <a:prstGeom prst="rect">
-            <a:avLst/>
-          </a:prstGeom>
-          <a:noFill/>
-          <a:ln/>
-        </p:spPr>
-        <p:txBody>
-          <a:bodyPr wrap="square" lIns="0" tIns="0" rIns="0" bIns="0" rtlCol="0" anchor="ctr"/>
-          <a:lstStyle/>
-          <a:p>
-            <a:pPr algn="ctr" indent="0" marL="0">
-              <a:buNone/>
-            </a:pPr>
-            <a:r>
-              <a:rPr lang="en-US" sz="1500" b="1" dirty="0">
-                <a:solidFill>
-                  <a:srgbClr val="2E7D32"/>
-                </a:solidFill>
-                <a:latin typeface="Calibri" pitchFamily="34" charset="0"/>
-                <a:ea typeface="Calibri" pitchFamily="34" charset="-122"/>
-                <a:cs typeface="Calibri" pitchFamily="34" charset="-120"/>
-              </a:rPr>
-              <a:t>✓</a:t>
-            </a:r>
-            <a:endParaRPr lang="en-US" sz="1500" dirty="0"/>
-          </a:p>
-        </p:txBody>
-      </p:sp>
-      <p:sp>
-        <p:nvSpPr>
-          <p:cNvPr id="28" name="Text 25"/>
-          <p:cNvSpPr/>
-          <p:nvPr/>
-        </p:nvSpPr>
-        <p:spPr>
-          <a:xfrm>
-            <a:off x="1298448" y="4690872"/>
-            <a:ext cx="4480560" cy="274320"/>
+          <p:cNvPr id="23" name="Text 20"/>
+          <p:cNvSpPr/>
+          <p:nvPr/>
+        </p:nvSpPr>
+        <p:spPr>
+          <a:xfrm>
+            <a:off x="1115568" y="4690872"/>
+            <a:ext cx="4663440" cy="274320"/>
           </a:xfrm>
           <a:prstGeom prst="rect">
             <a:avLst/>
@@ -9921,14 +9492,14 @@
       </p:sp>
       <p:sp>
         <p:nvSpPr>
-          <p:cNvPr id="29" name="Text 26"/>
-          <p:cNvSpPr/>
-          <p:nvPr/>
-        </p:nvSpPr>
-        <p:spPr>
-          <a:xfrm>
-            <a:off x="1298448" y="4992624"/>
-            <a:ext cx="4480560" cy="658368"/>
+          <p:cNvPr id="24" name="Text 21"/>
+          <p:cNvSpPr/>
+          <p:nvPr/>
+        </p:nvSpPr>
+        <p:spPr>
+          <a:xfrm>
+            <a:off x="1115568" y="4992624"/>
+            <a:ext cx="4663440" cy="658368"/>
           </a:xfrm>
           <a:prstGeom prst="rect">
             <a:avLst/>
@@ -9963,7 +9534,7 @@
       </p:sp>
       <p:sp>
         <p:nvSpPr>
-          <p:cNvPr id="30" name="Shape 27"/>
+          <p:cNvPr id="25" name="Shape 22"/>
           <p:cNvSpPr/>
           <p:nvPr/>
         </p:nvSpPr>
@@ -9990,24 +9561,24 @@
       </p:sp>
       <p:sp>
         <p:nvSpPr>
-          <p:cNvPr id="31" name="Shape 28"/>
-          <p:cNvSpPr/>
-          <p:nvPr/>
-        </p:nvSpPr>
-        <p:spPr>
-          <a:xfrm>
-            <a:off x="6446520" y="4727448"/>
-            <a:ext cx="384048" cy="384048"/>
+          <p:cNvPr id="26" name="Shape 23"/>
+          <p:cNvSpPr/>
+          <p:nvPr/>
+        </p:nvSpPr>
+        <p:spPr>
+          <a:xfrm>
+            <a:off x="6492240" y="4791456"/>
+            <a:ext cx="146304" cy="146304"/>
           </a:xfrm>
           <a:prstGeom prst="ellipse">
             <a:avLst/>
           </a:prstGeom>
           <a:solidFill>
-            <a:srgbClr val="E5F2E6"/>
+            <a:srgbClr val="2E7D32"/>
           </a:solidFill>
           <a:ln w="12700">
             <a:solidFill>
-              <a:srgbClr val="E5F2E6"/>
+              <a:srgbClr val="2E7D32"/>
             </a:solidFill>
             <a:prstDash val="solid"/>
           </a:ln>
@@ -10015,53 +9586,14 @@
       </p:sp>
       <p:sp>
         <p:nvSpPr>
-          <p:cNvPr id="32" name="Text 29"/>
-          <p:cNvSpPr/>
-          <p:nvPr/>
-        </p:nvSpPr>
-        <p:spPr>
-          <a:xfrm>
-            <a:off x="6446520" y="4727448"/>
-            <a:ext cx="384048" cy="384048"/>
-          </a:xfrm>
-          <a:prstGeom prst="rect">
-            <a:avLst/>
-          </a:prstGeom>
-          <a:noFill/>
-          <a:ln/>
-        </p:spPr>
-        <p:txBody>
-          <a:bodyPr wrap="square" lIns="0" tIns="0" rIns="0" bIns="0" rtlCol="0" anchor="ctr"/>
-          <a:lstStyle/>
-          <a:p>
-            <a:pPr algn="ctr" indent="0" marL="0">
-              <a:buNone/>
-            </a:pPr>
-            <a:r>
-              <a:rPr lang="en-US" sz="1500" b="1" dirty="0">
-                <a:solidFill>
-                  <a:srgbClr val="2E7D32"/>
-                </a:solidFill>
-                <a:latin typeface="Calibri" pitchFamily="34" charset="0"/>
-                <a:ea typeface="Calibri" pitchFamily="34" charset="-122"/>
-                <a:cs typeface="Calibri" pitchFamily="34" charset="-120"/>
-              </a:rPr>
-              <a:t>✓</a:t>
-            </a:r>
-            <a:endParaRPr lang="en-US" sz="1500" dirty="0"/>
-          </a:p>
-        </p:txBody>
-      </p:sp>
-      <p:sp>
-        <p:nvSpPr>
-          <p:cNvPr id="33" name="Text 30"/>
-          <p:cNvSpPr/>
-          <p:nvPr/>
-        </p:nvSpPr>
-        <p:spPr>
-          <a:xfrm>
-            <a:off x="6967728" y="4690872"/>
-            <a:ext cx="4480560" cy="274320"/>
+          <p:cNvPr id="27" name="Text 24"/>
+          <p:cNvSpPr/>
+          <p:nvPr/>
+        </p:nvSpPr>
+        <p:spPr>
+          <a:xfrm>
+            <a:off x="6784848" y="4690872"/>
+            <a:ext cx="4663440" cy="274320"/>
           </a:xfrm>
           <a:prstGeom prst="rect">
             <a:avLst/>
@@ -10093,14 +9625,14 @@
       </p:sp>
       <p:sp>
         <p:nvSpPr>
-          <p:cNvPr id="34" name="Text 31"/>
-          <p:cNvSpPr/>
-          <p:nvPr/>
-        </p:nvSpPr>
-        <p:spPr>
-          <a:xfrm>
-            <a:off x="6967728" y="4992624"/>
-            <a:ext cx="4480560" cy="658368"/>
+          <p:cNvPr id="28" name="Text 25"/>
+          <p:cNvSpPr/>
+          <p:nvPr/>
+        </p:nvSpPr>
+        <p:spPr>
+          <a:xfrm>
+            <a:off x="6784848" y="4992624"/>
+            <a:ext cx="4663440" cy="658368"/>
           </a:xfrm>
           <a:prstGeom prst="rect">
             <a:avLst/>
@@ -10127,7 +9659,7 @@
                 <a:ea typeface="Calibri" pitchFamily="34" charset="-122"/>
                 <a:cs typeface="Calibri" pitchFamily="34" charset="-120"/>
               </a:rPr>
-              <a:t>With no API key the client is never constructed; routes return a clean 503. The key never reaches the browser.</a:t>
+              <a:t>With no API key the client is never constructed and routes return a clean 503. The key never reaches the browser.</a:t>
             </a:r>
             <a:endParaRPr lang="en-US" sz="1100" dirty="0"/>
           </a:p>
@@ -10135,7 +9667,7 @@
       </p:sp>
       <p:sp>
         <p:nvSpPr>
-          <p:cNvPr id="35" name="Text 32"/>
+          <p:cNvPr id="29" name="Text 26"/>
           <p:cNvSpPr/>
           <p:nvPr/>
         </p:nvSpPr>
@@ -10166,7 +9698,7 @@
                 <a:ea typeface="Calibri" pitchFamily="34" charset="-122"/>
                 <a:cs typeface="Calibri" pitchFamily="34" charset="-120"/>
               </a:rPr>
-              <a:t>XD House · Ma'aden ARGP Security &amp; Assurance · 15 July 2026</a:t>
+              <a:t>XD House   |   Ma'aden ARGP Security &amp; Assurance   |   15 July 2026</a:t>
             </a:r>
             <a:endParaRPr lang="en-US" sz="900" dirty="0"/>
           </a:p>
@@ -10314,14 +9846,14 @@
         </p:nvSpPr>
         <p:spPr>
           <a:xfrm>
-            <a:off x="566928" y="1572768"/>
-            <a:ext cx="274320" cy="274320"/>
+            <a:off x="603504" y="1636776"/>
+            <a:ext cx="146304" cy="146304"/>
           </a:xfrm>
           <a:prstGeom prst="ellipse">
             <a:avLst/>
           </a:prstGeom>
           <a:solidFill>
-            <a:srgbClr val="23242A"/>
+            <a:srgbClr val="C9A227"/>
           </a:solidFill>
           <a:ln w="12700">
             <a:solidFill>
@@ -10339,45 +9871,6 @@
         </p:nvSpPr>
         <p:spPr>
           <a:xfrm>
-            <a:off x="566928" y="1572768"/>
-            <a:ext cx="274320" cy="274320"/>
-          </a:xfrm>
-          <a:prstGeom prst="rect">
-            <a:avLst/>
-          </a:prstGeom>
-          <a:noFill/>
-          <a:ln/>
-        </p:spPr>
-        <p:txBody>
-          <a:bodyPr wrap="square" lIns="0" tIns="0" rIns="0" bIns="0" rtlCol="0" anchor="ctr"/>
-          <a:lstStyle/>
-          <a:p>
-            <a:pPr algn="ctr" indent="0" marL="0">
-              <a:buNone/>
-            </a:pPr>
-            <a:r>
-              <a:rPr lang="en-US" sz="1100" b="1" dirty="0">
-                <a:solidFill>
-                  <a:srgbClr val="C9A227"/>
-                </a:solidFill>
-                <a:latin typeface="Calibri" pitchFamily="34" charset="0"/>
-                <a:ea typeface="Calibri" pitchFamily="34" charset="-122"/>
-                <a:cs typeface="Calibri" pitchFamily="34" charset="-120"/>
-              </a:rPr>
-              <a:t>✓</a:t>
-            </a:r>
-            <a:endParaRPr lang="en-US" sz="1100" dirty="0"/>
-          </a:p>
-        </p:txBody>
-      </p:sp>
-      <p:sp>
-        <p:nvSpPr>
-          <p:cNvPr id="7" name="Text 4"/>
-          <p:cNvSpPr/>
-          <p:nvPr/>
-        </p:nvSpPr>
-        <p:spPr>
-          <a:xfrm>
             <a:off x="987552" y="1463040"/>
             <a:ext cx="4206240" cy="475488"/>
           </a:xfrm>
@@ -10403,7 +9896,7 @@
                 <a:ea typeface="Calibri" pitchFamily="34" charset="-122"/>
                 <a:cs typeface="Calibri" pitchFamily="34" charset="-120"/>
               </a:rPr>
-              <a:t>Data residency — Kingdom of Saudi Arabia</a:t>
+              <a:t>Data residency: Kingdom of Saudi Arabia</a:t>
             </a:r>
             <a:endParaRPr lang="en-US" sz="1300" dirty="0"/>
           </a:p>
@@ -10411,7 +9904,7 @@
       </p:sp>
       <p:sp>
         <p:nvSpPr>
-          <p:cNvPr id="8" name="Text 5"/>
+          <p:cNvPr id="7" name="Text 4"/>
           <p:cNvSpPr/>
           <p:nvPr/>
         </p:nvSpPr>
@@ -10442,7 +9935,7 @@
                 <a:ea typeface="Calibri" pitchFamily="34" charset="-122"/>
                 <a:cs typeface="Calibri" pitchFamily="34" charset="-120"/>
               </a:rPr>
-              <a:t>Azure App Service + Azure Database for PostgreSQL, Riyadh region. No Ma'aden production data offshore.</a:t>
+              <a:t>Azure App Service and Azure Database for PostgreSQL, Riyadh region. No Ma'aden production data offshore.</a:t>
             </a:r>
             <a:endParaRPr lang="en-US" sz="1150" dirty="0"/>
           </a:p>
@@ -10450,20 +9943,20 @@
       </p:sp>
       <p:sp>
         <p:nvSpPr>
-          <p:cNvPr id="9" name="Shape 6"/>
-          <p:cNvSpPr/>
-          <p:nvPr/>
-        </p:nvSpPr>
-        <p:spPr>
-          <a:xfrm>
-            <a:off x="566928" y="2194560"/>
-            <a:ext cx="274320" cy="274320"/>
+          <p:cNvPr id="8" name="Shape 5"/>
+          <p:cNvSpPr/>
+          <p:nvPr/>
+        </p:nvSpPr>
+        <p:spPr>
+          <a:xfrm>
+            <a:off x="603504" y="2258568"/>
+            <a:ext cx="146304" cy="146304"/>
           </a:xfrm>
           <a:prstGeom prst="ellipse">
             <a:avLst/>
           </a:prstGeom>
           <a:solidFill>
-            <a:srgbClr val="23242A"/>
+            <a:srgbClr val="C9A227"/>
           </a:solidFill>
           <a:ln w="12700">
             <a:solidFill>
@@ -10475,46 +9968,7 @@
       </p:sp>
       <p:sp>
         <p:nvSpPr>
-          <p:cNvPr id="10" name="Text 7"/>
-          <p:cNvSpPr/>
-          <p:nvPr/>
-        </p:nvSpPr>
-        <p:spPr>
-          <a:xfrm>
-            <a:off x="566928" y="2194560"/>
-            <a:ext cx="274320" cy="274320"/>
-          </a:xfrm>
-          <a:prstGeom prst="rect">
-            <a:avLst/>
-          </a:prstGeom>
-          <a:noFill/>
-          <a:ln/>
-        </p:spPr>
-        <p:txBody>
-          <a:bodyPr wrap="square" lIns="0" tIns="0" rIns="0" bIns="0" rtlCol="0" anchor="ctr"/>
-          <a:lstStyle/>
-          <a:p>
-            <a:pPr algn="ctr" indent="0" marL="0">
-              <a:buNone/>
-            </a:pPr>
-            <a:r>
-              <a:rPr lang="en-US" sz="1100" b="1" dirty="0">
-                <a:solidFill>
-                  <a:srgbClr val="C9A227"/>
-                </a:solidFill>
-                <a:latin typeface="Calibri" pitchFamily="34" charset="0"/>
-                <a:ea typeface="Calibri" pitchFamily="34" charset="-122"/>
-                <a:cs typeface="Calibri" pitchFamily="34" charset="-120"/>
-              </a:rPr>
-              <a:t>✓</a:t>
-            </a:r>
-            <a:endParaRPr lang="en-US" sz="1100" dirty="0"/>
-          </a:p>
-        </p:txBody>
-      </p:sp>
-      <p:sp>
-        <p:nvSpPr>
-          <p:cNvPr id="11" name="Text 8"/>
+          <p:cNvPr id="9" name="Text 6"/>
           <p:cNvSpPr/>
           <p:nvPr/>
         </p:nvSpPr>
@@ -10545,7 +9999,7 @@
                 <a:ea typeface="Calibri" pitchFamily="34" charset="-122"/>
                 <a:cs typeface="Calibri" pitchFamily="34" charset="-120"/>
               </a:rPr>
-              <a:t>Azure AD + ADFS SSO, SAML 2.0, MFA</a:t>
+              <a:t>Azure AD and ADFS SSO, SAML 2.0, MFA</a:t>
             </a:r>
             <a:endParaRPr lang="en-US" sz="1300" dirty="0"/>
           </a:p>
@@ -10553,7 +10007,7 @@
       </p:sp>
       <p:sp>
         <p:nvSpPr>
-          <p:cNvPr id="12" name="Text 9"/>
+          <p:cNvPr id="10" name="Text 7"/>
           <p:cNvSpPr/>
           <p:nvPr/>
         </p:nvSpPr>
@@ -10592,20 +10046,20 @@
       </p:sp>
       <p:sp>
         <p:nvSpPr>
-          <p:cNvPr id="13" name="Shape 10"/>
-          <p:cNvSpPr/>
-          <p:nvPr/>
-        </p:nvSpPr>
-        <p:spPr>
-          <a:xfrm>
-            <a:off x="566928" y="2816352"/>
-            <a:ext cx="274320" cy="274320"/>
+          <p:cNvPr id="11" name="Shape 8"/>
+          <p:cNvSpPr/>
+          <p:nvPr/>
+        </p:nvSpPr>
+        <p:spPr>
+          <a:xfrm>
+            <a:off x="603504" y="2880360"/>
+            <a:ext cx="146304" cy="146304"/>
           </a:xfrm>
           <a:prstGeom prst="ellipse">
             <a:avLst/>
           </a:prstGeom>
           <a:solidFill>
-            <a:srgbClr val="23242A"/>
+            <a:srgbClr val="C9A227"/>
           </a:solidFill>
           <a:ln w="12700">
             <a:solidFill>
@@ -10617,46 +10071,7 @@
       </p:sp>
       <p:sp>
         <p:nvSpPr>
-          <p:cNvPr id="14" name="Text 11"/>
-          <p:cNvSpPr/>
-          <p:nvPr/>
-        </p:nvSpPr>
-        <p:spPr>
-          <a:xfrm>
-            <a:off x="566928" y="2816352"/>
-            <a:ext cx="274320" cy="274320"/>
-          </a:xfrm>
-          <a:prstGeom prst="rect">
-            <a:avLst/>
-          </a:prstGeom>
-          <a:noFill/>
-          <a:ln/>
-        </p:spPr>
-        <p:txBody>
-          <a:bodyPr wrap="square" lIns="0" tIns="0" rIns="0" bIns="0" rtlCol="0" anchor="ctr"/>
-          <a:lstStyle/>
-          <a:p>
-            <a:pPr algn="ctr" indent="0" marL="0">
-              <a:buNone/>
-            </a:pPr>
-            <a:r>
-              <a:rPr lang="en-US" sz="1100" b="1" dirty="0">
-                <a:solidFill>
-                  <a:srgbClr val="C9A227"/>
-                </a:solidFill>
-                <a:latin typeface="Calibri" pitchFamily="34" charset="0"/>
-                <a:ea typeface="Calibri" pitchFamily="34" charset="-122"/>
-                <a:cs typeface="Calibri" pitchFamily="34" charset="-120"/>
-              </a:rPr>
-              <a:t>✓</a:t>
-            </a:r>
-            <a:endParaRPr lang="en-US" sz="1100" dirty="0"/>
-          </a:p>
-        </p:txBody>
-      </p:sp>
-      <p:sp>
-        <p:nvSpPr>
-          <p:cNvPr id="15" name="Text 12"/>
+          <p:cNvPr id="12" name="Text 9"/>
           <p:cNvSpPr/>
           <p:nvPr/>
         </p:nvSpPr>
@@ -10695,7 +10110,7 @@
       </p:sp>
       <p:sp>
         <p:nvSpPr>
-          <p:cNvPr id="16" name="Text 13"/>
+          <p:cNvPr id="13" name="Text 10"/>
           <p:cNvSpPr/>
           <p:nvPr/>
         </p:nvSpPr>
@@ -10726,7 +10141,7 @@
                 <a:ea typeface="Calibri" pitchFamily="34" charset="-122"/>
                 <a:cs typeface="Calibri" pitchFamily="34" charset="-120"/>
               </a:rPr>
-              <a:t>TLS 1.2+ browser→app→database, HSTS at the edge. Azure TDE at rest. Keys in Azure Key Vault.</a:t>
+              <a:t>TLS 1.2+ from browser to app to database, HSTS at the edge. Azure TDE at rest. Keys in Azure Key Vault.</a:t>
             </a:r>
             <a:endParaRPr lang="en-US" sz="1150" dirty="0"/>
           </a:p>
@@ -10734,20 +10149,20 @@
       </p:sp>
       <p:sp>
         <p:nvSpPr>
-          <p:cNvPr id="17" name="Shape 14"/>
-          <p:cNvSpPr/>
-          <p:nvPr/>
-        </p:nvSpPr>
-        <p:spPr>
-          <a:xfrm>
-            <a:off x="566928" y="3438144"/>
-            <a:ext cx="274320" cy="274320"/>
+          <p:cNvPr id="14" name="Shape 11"/>
+          <p:cNvSpPr/>
+          <p:nvPr/>
+        </p:nvSpPr>
+        <p:spPr>
+          <a:xfrm>
+            <a:off x="603504" y="3502152"/>
+            <a:ext cx="146304" cy="146304"/>
           </a:xfrm>
           <a:prstGeom prst="ellipse">
             <a:avLst/>
           </a:prstGeom>
           <a:solidFill>
-            <a:srgbClr val="23242A"/>
+            <a:srgbClr val="C9A227"/>
           </a:solidFill>
           <a:ln w="12700">
             <a:solidFill>
@@ -10759,46 +10174,7 @@
       </p:sp>
       <p:sp>
         <p:nvSpPr>
-          <p:cNvPr id="18" name="Text 15"/>
-          <p:cNvSpPr/>
-          <p:nvPr/>
-        </p:nvSpPr>
-        <p:spPr>
-          <a:xfrm>
-            <a:off x="566928" y="3438144"/>
-            <a:ext cx="274320" cy="274320"/>
-          </a:xfrm>
-          <a:prstGeom prst="rect">
-            <a:avLst/>
-          </a:prstGeom>
-          <a:noFill/>
-          <a:ln/>
-        </p:spPr>
-        <p:txBody>
-          <a:bodyPr wrap="square" lIns="0" tIns="0" rIns="0" bIns="0" rtlCol="0" anchor="ctr"/>
-          <a:lstStyle/>
-          <a:p>
-            <a:pPr algn="ctr" indent="0" marL="0">
-              <a:buNone/>
-            </a:pPr>
-            <a:r>
-              <a:rPr lang="en-US" sz="1100" b="1" dirty="0">
-                <a:solidFill>
-                  <a:srgbClr val="C9A227"/>
-                </a:solidFill>
-                <a:latin typeface="Calibri" pitchFamily="34" charset="0"/>
-                <a:ea typeface="Calibri" pitchFamily="34" charset="-122"/>
-                <a:cs typeface="Calibri" pitchFamily="34" charset="-120"/>
-              </a:rPr>
-              <a:t>✓</a:t>
-            </a:r>
-            <a:endParaRPr lang="en-US" sz="1100" dirty="0"/>
-          </a:p>
-        </p:txBody>
-      </p:sp>
-      <p:sp>
-        <p:nvSpPr>
-          <p:cNvPr id="19" name="Text 16"/>
+          <p:cNvPr id="15" name="Text 12"/>
           <p:cNvSpPr/>
           <p:nvPr/>
         </p:nvSpPr>
@@ -10837,7 +10213,7 @@
       </p:sp>
       <p:sp>
         <p:nvSpPr>
-          <p:cNvPr id="20" name="Text 17"/>
+          <p:cNvPr id="16" name="Text 13"/>
           <p:cNvSpPr/>
           <p:nvPr/>
         </p:nvSpPr>
@@ -10876,20 +10252,20 @@
       </p:sp>
       <p:sp>
         <p:nvSpPr>
-          <p:cNvPr id="21" name="Shape 18"/>
-          <p:cNvSpPr/>
-          <p:nvPr/>
-        </p:nvSpPr>
-        <p:spPr>
-          <a:xfrm>
-            <a:off x="566928" y="4059936"/>
-            <a:ext cx="274320" cy="274320"/>
+          <p:cNvPr id="17" name="Shape 14"/>
+          <p:cNvSpPr/>
+          <p:nvPr/>
+        </p:nvSpPr>
+        <p:spPr>
+          <a:xfrm>
+            <a:off x="603504" y="4123944"/>
+            <a:ext cx="146304" cy="146304"/>
           </a:xfrm>
           <a:prstGeom prst="ellipse">
             <a:avLst/>
           </a:prstGeom>
           <a:solidFill>
-            <a:srgbClr val="23242A"/>
+            <a:srgbClr val="C9A227"/>
           </a:solidFill>
           <a:ln w="12700">
             <a:solidFill>
@@ -10901,46 +10277,7 @@
       </p:sp>
       <p:sp>
         <p:nvSpPr>
-          <p:cNvPr id="22" name="Text 19"/>
-          <p:cNvSpPr/>
-          <p:nvPr/>
-        </p:nvSpPr>
-        <p:spPr>
-          <a:xfrm>
-            <a:off x="566928" y="4059936"/>
-            <a:ext cx="274320" cy="274320"/>
-          </a:xfrm>
-          <a:prstGeom prst="rect">
-            <a:avLst/>
-          </a:prstGeom>
-          <a:noFill/>
-          <a:ln/>
-        </p:spPr>
-        <p:txBody>
-          <a:bodyPr wrap="square" lIns="0" tIns="0" rIns="0" bIns="0" rtlCol="0" anchor="ctr"/>
-          <a:lstStyle/>
-          <a:p>
-            <a:pPr algn="ctr" indent="0" marL="0">
-              <a:buNone/>
-            </a:pPr>
-            <a:r>
-              <a:rPr lang="en-US" sz="1100" b="1" dirty="0">
-                <a:solidFill>
-                  <a:srgbClr val="C9A227"/>
-                </a:solidFill>
-                <a:latin typeface="Calibri" pitchFamily="34" charset="0"/>
-                <a:ea typeface="Calibri" pitchFamily="34" charset="-122"/>
-                <a:cs typeface="Calibri" pitchFamily="34" charset="-120"/>
-              </a:rPr>
-              <a:t>✓</a:t>
-            </a:r>
-            <a:endParaRPr lang="en-US" sz="1100" dirty="0"/>
-          </a:p>
-        </p:txBody>
-      </p:sp>
-      <p:sp>
-        <p:nvSpPr>
-          <p:cNvPr id="23" name="Text 20"/>
+          <p:cNvPr id="18" name="Text 15"/>
           <p:cNvSpPr/>
           <p:nvPr/>
         </p:nvSpPr>
@@ -10979,7 +10316,7 @@
       </p:sp>
       <p:sp>
         <p:nvSpPr>
-          <p:cNvPr id="24" name="Text 21"/>
+          <p:cNvPr id="19" name="Text 16"/>
           <p:cNvSpPr/>
           <p:nvPr/>
         </p:nvSpPr>
@@ -11010,7 +10347,7 @@
                 <a:ea typeface="Calibri" pitchFamily="34" charset="-122"/>
                 <a:cs typeface="Calibri" pitchFamily="34" charset="-120"/>
               </a:rPr>
-              <a:t>Built and demonstrable today in the CDE sample — who, what, before/after, when.</a:t>
+              <a:t>Built and demonstrable today in the CDE sample: who, what, before and after, when.</a:t>
             </a:r>
             <a:endParaRPr lang="en-US" sz="1150" dirty="0"/>
           </a:p>
@@ -11018,20 +10355,20 @@
       </p:sp>
       <p:sp>
         <p:nvSpPr>
-          <p:cNvPr id="25" name="Shape 22"/>
-          <p:cNvSpPr/>
-          <p:nvPr/>
-        </p:nvSpPr>
-        <p:spPr>
-          <a:xfrm>
-            <a:off x="566928" y="4681728"/>
-            <a:ext cx="274320" cy="274320"/>
+          <p:cNvPr id="20" name="Shape 17"/>
+          <p:cNvSpPr/>
+          <p:nvPr/>
+        </p:nvSpPr>
+        <p:spPr>
+          <a:xfrm>
+            <a:off x="603504" y="4745736"/>
+            <a:ext cx="146304" cy="146304"/>
           </a:xfrm>
           <a:prstGeom prst="ellipse">
             <a:avLst/>
           </a:prstGeom>
           <a:solidFill>
-            <a:srgbClr val="23242A"/>
+            <a:srgbClr val="C9A227"/>
           </a:solidFill>
           <a:ln w="12700">
             <a:solidFill>
@@ -11043,46 +10380,7 @@
       </p:sp>
       <p:sp>
         <p:nvSpPr>
-          <p:cNvPr id="26" name="Text 23"/>
-          <p:cNvSpPr/>
-          <p:nvPr/>
-        </p:nvSpPr>
-        <p:spPr>
-          <a:xfrm>
-            <a:off x="566928" y="4681728"/>
-            <a:ext cx="274320" cy="274320"/>
-          </a:xfrm>
-          <a:prstGeom prst="rect">
-            <a:avLst/>
-          </a:prstGeom>
-          <a:noFill/>
-          <a:ln/>
-        </p:spPr>
-        <p:txBody>
-          <a:bodyPr wrap="square" lIns="0" tIns="0" rIns="0" bIns="0" rtlCol="0" anchor="ctr"/>
-          <a:lstStyle/>
-          <a:p>
-            <a:pPr algn="ctr" indent="0" marL="0">
-              <a:buNone/>
-            </a:pPr>
-            <a:r>
-              <a:rPr lang="en-US" sz="1100" b="1" dirty="0">
-                <a:solidFill>
-                  <a:srgbClr val="C9A227"/>
-                </a:solidFill>
-                <a:latin typeface="Calibri" pitchFamily="34" charset="0"/>
-                <a:ea typeface="Calibri" pitchFamily="34" charset="-122"/>
-                <a:cs typeface="Calibri" pitchFamily="34" charset="-120"/>
-              </a:rPr>
-              <a:t>✓</a:t>
-            </a:r>
-            <a:endParaRPr lang="en-US" sz="1100" dirty="0"/>
-          </a:p>
-        </p:txBody>
-      </p:sp>
-      <p:sp>
-        <p:nvSpPr>
-          <p:cNvPr id="27" name="Text 24"/>
+          <p:cNvPr id="21" name="Text 18"/>
           <p:cNvSpPr/>
           <p:nvPr/>
         </p:nvSpPr>
@@ -11121,7 +10419,7 @@
       </p:sp>
       <p:sp>
         <p:nvSpPr>
-          <p:cNvPr id="28" name="Text 25"/>
+          <p:cNvPr id="22" name="Text 19"/>
           <p:cNvSpPr/>
           <p:nvPr/>
         </p:nvSpPr>
@@ -11152,7 +10450,7 @@
                 <a:ea typeface="Calibri" pitchFamily="34" charset="-122"/>
                 <a:cs typeface="Calibri" pitchFamily="34" charset="-120"/>
               </a:rPr>
-              <a:t>OpenAPI spec published; every mutating route role-gated server-side.</a:t>
+              <a:t>OpenAPI spec published. Every mutating route is role-gated server-side.</a:t>
             </a:r>
             <a:endParaRPr lang="en-US" sz="1150" dirty="0"/>
           </a:p>
@@ -11160,7 +10458,7 @@
       </p:sp>
       <p:sp>
         <p:nvSpPr>
-          <p:cNvPr id="29" name="Shape 26"/>
+          <p:cNvPr id="23" name="Shape 20"/>
           <p:cNvSpPr/>
           <p:nvPr/>
         </p:nvSpPr>
@@ -11187,7 +10485,7 @@
       </p:sp>
       <p:sp>
         <p:nvSpPr>
-          <p:cNvPr id="30" name="Text 27"/>
+          <p:cNvPr id="24" name="Text 21"/>
           <p:cNvSpPr/>
           <p:nvPr/>
         </p:nvSpPr>
@@ -11218,7 +10516,7 @@
                 <a:ea typeface="Calibri" pitchFamily="34" charset="-122"/>
                 <a:cs typeface="Calibri" pitchFamily="34" charset="-120"/>
               </a:rPr>
-              <a:t>These are commitments for the delivered production system. The pre-award demo you have seen implements the audit trail and role model today; the identity, transport and hosting controls arrive with the Azure deployment.</a:t>
+              <a:t>These are commitments for the delivered production system. The pre-award demo you have seen implements the audit trail and role model today. The identity, transport and hosting controls arrive with the Azure deployment.</a:t>
             </a:r>
             <a:endParaRPr lang="en-US" sz="1150" dirty="0"/>
           </a:p>
@@ -11226,7 +10524,7 @@
       </p:sp>
       <p:sp>
         <p:nvSpPr>
-          <p:cNvPr id="31" name="Text 28"/>
+          <p:cNvPr id="25" name="Text 22"/>
           <p:cNvSpPr/>
           <p:nvPr/>
         </p:nvSpPr>
@@ -11257,7 +10555,7 @@
                 <a:ea typeface="Calibri" pitchFamily="34" charset="-122"/>
                 <a:cs typeface="Calibri" pitchFamily="34" charset="-120"/>
               </a:rPr>
-              <a:t>XD House · Ma'aden ARGP Security &amp; Assurance · 15 July 2026</a:t>
+              <a:t>XD House   |   Ma'aden ARGP Security &amp; Assurance   |   15 July 2026</a:t>
             </a:r>
             <a:endParaRPr lang="en-US" sz="900" dirty="0"/>
           </a:p>
@@ -11481,7 +10779,7 @@
                 <a:ea typeface="Calibri" pitchFamily="34" charset="-122"/>
                 <a:cs typeface="Calibri" pitchFamily="34" charset="-120"/>
               </a:rPr>
-              <a:t>BSI Kitemark™ — BIM Design and Construction, and BIM Security</a:t>
+              <a:t>BSI Kitemark for BIM Design and Construction, and for BIM Security</a:t>
             </a:r>
             <a:endParaRPr lang="en-US" sz="1350" dirty="0"/>
           </a:p>
@@ -11523,7 +10821,7 @@
                 <a:ea typeface="Calibri" pitchFamily="34" charset="-122"/>
                 <a:cs typeface="Calibri" pitchFamily="34" charset="-120"/>
               </a:rPr>
-              <a:t>BIM Security addresses security-minded information management for built assets — directly relevant to a Common Data Environment.</a:t>
+              <a:t>BIM Security addresses security-minded information management for built assets, which is directly relevant to a Common Data Environment.</a:t>
             </a:r>
             <a:endParaRPr lang="en-US" sz="1100" dirty="0"/>
           </a:p>
@@ -11660,7 +10958,7 @@
                 <a:ea typeface="Calibri" pitchFamily="34" charset="-122"/>
                 <a:cs typeface="Calibri" pitchFamily="34" charset="-120"/>
               </a:rPr>
-              <a:t>A certification claim is the first thing a security reviewer verifies. An unsupportable one ends the review — and the relationship.</a:t>
+              <a:t>A certification claim is the first thing a security reviewer verifies. An unsupportable one ends the review, and the relationship.</a:t>
             </a:r>
             <a:endParaRPr lang="en-US" sz="1350" dirty="0"/>
           </a:p>
@@ -11728,7 +11026,7 @@
                 <a:ea typeface="Calibri" pitchFamily="34" charset="-122"/>
                 <a:cs typeface="Calibri" pitchFamily="34" charset="-120"/>
               </a:rPr>
-              <a:t>Certificate numbers and scope available on request · XD House · 15 July 2026</a:t>
+              <a:t>Certificate numbers and scope available on request.</a:t>
             </a:r>
             <a:endParaRPr lang="en-US" sz="900" dirty="0"/>
           </a:p>
@@ -11838,7 +11136,7 @@
                 <a:ea typeface="Calibri" pitchFamily="34" charset="-122"/>
                 <a:cs typeface="Calibri" pitchFamily="34" charset="-120"/>
               </a:rPr>
-              <a:t>Five documents — available to your reviewers today</a:t>
+              <a:t>Five documents, available to your reviewers today</a:t>
             </a:r>
             <a:endParaRPr lang="en-US" sz="1300" dirty="0"/>
           </a:p>
@@ -12177,7 +11475,7 @@
                 <a:ea typeface="Calibri" pitchFamily="34" charset="-122"/>
                 <a:cs typeface="Calibri" pitchFamily="34" charset="-120"/>
               </a:rPr>
-              <a:t>Production Readiness Audit — 13 Layers</a:t>
+              <a:t>Production Readiness Audit, 13 Layers</a:t>
             </a:r>
             <a:endParaRPr lang="en-US" sz="1350" dirty="0"/>
           </a:p>
@@ -12387,7 +11685,7 @@
                 <a:ea typeface="Calibri" pitchFamily="34" charset="-122"/>
                 <a:cs typeface="Calibri" pitchFamily="34" charset="-120"/>
               </a:rPr>
-              <a:t>Penetration Test — Scope &amp; Commission Plan</a:t>
+              <a:t>Penetration Test, Scope &amp; Commission Plan</a:t>
             </a:r>
             <a:endParaRPr lang="en-US" sz="1350" dirty="0"/>
           </a:p>
@@ -12426,7 +11724,7 @@
                 <a:ea typeface="Calibri" pitchFamily="34" charset="-122"/>
                 <a:cs typeface="Calibri" pitchFamily="34" charset="-120"/>
               </a:rPr>
-              <a:t>What will be tested, by whom, and when — a plan, not a result</a:t>
+              <a:t>What will be tested, by whom, and when. A plan, not a result.</a:t>
             </a:r>
             <a:endParaRPr lang="en-US" sz="1100" dirty="0"/>
           </a:p>
@@ -12807,7 +12105,7 @@
                 <a:ea typeface="Calibri" pitchFamily="34" charset="-122"/>
                 <a:cs typeface="Calibri" pitchFamily="34" charset="-120"/>
               </a:rPr>
-              <a:t>Security Questionnaire — Pre-Answers</a:t>
+              <a:t>Security Questionnaire, Pre-Answers</a:t>
             </a:r>
             <a:endParaRPr lang="en-US" sz="1350" dirty="0"/>
           </a:p>
@@ -12846,7 +12144,7 @@
                 <a:ea typeface="Calibri" pitchFamily="34" charset="-122"/>
                 <a:cs typeface="Calibri" pitchFamily="34" charset="-120"/>
               </a:rPr>
-              <a:t>Demo-today vs production-committed, answered side by side</a:t>
+              <a:t>Demo-today against production-committed, answered side by side</a:t>
             </a:r>
             <a:endParaRPr lang="en-US" sz="1100" dirty="0"/>
           </a:p>
@@ -12990,7 +12288,7 @@
                 <a:ea typeface="Calibri" pitchFamily="34" charset="-122"/>
                 <a:cs typeface="Calibri" pitchFamily="34" charset="-120"/>
               </a:rPr>
-              <a:t>XD House · Ma'aden ARGP Security &amp; Assurance · 15 July 2026</a:t>
+              <a:t>XD House   |   Ma'aden ARGP Security &amp; Assurance   |   15 July 2026</a:t>
             </a:r>
             <a:endParaRPr lang="en-US" sz="900" dirty="0"/>
           </a:p>

</xml_diff>

<commit_message>
Deck binary: the real build, with ticks restored
The previous commit claimed the ticks were restored but shipped the stale
.pptx: PowerPoint still had the file locked, so the copy silently failed
and the old binary went in. This is the actual rebuilt deck.

Verified against the packed slide XML in the committed file: 15 ticks
present, zero em dashes, zero arrows, zero middots.

Co-Authored-By: Claude Opus 4.8 <noreply@anthropic.com>
</commit_message>
<xml_diff>
--- a/RFQ Doc/2026.07.15 Security Pack/Maaden ARGP - Security & Assurance.pptx
+++ b/RFQ Doc/2026.07.15 Security Pack/Maaden ARGP - Security & Assurance.pptx
@@ -2053,8 +2053,8 @@
         </p:nvSpPr>
         <p:spPr>
           <a:xfrm>
-            <a:off x="685800" y="2825496"/>
-            <a:ext cx="146304" cy="146304"/>
+            <a:off x="658368" y="2752344"/>
+            <a:ext cx="310896" cy="310896"/>
           </a:xfrm>
           <a:prstGeom prst="ellipse">
             <a:avLst/>
@@ -2078,6 +2078,45 @@
         </p:nvSpPr>
         <p:spPr>
           <a:xfrm>
+            <a:off x="658368" y="2752344"/>
+            <a:ext cx="310896" cy="310896"/>
+          </a:xfrm>
+          <a:prstGeom prst="rect">
+            <a:avLst/>
+          </a:prstGeom>
+          <a:noFill/>
+          <a:ln/>
+        </p:spPr>
+        <p:txBody>
+          <a:bodyPr wrap="square" lIns="0" tIns="0" rIns="0" bIns="0" rtlCol="0" anchor="ctr"/>
+          <a:lstStyle/>
+          <a:p>
+            <a:pPr algn="ctr" indent="0" marL="0">
+              <a:buNone/>
+            </a:pPr>
+            <a:r>
+              <a:rPr lang="en-US" sz="1224" b="1" dirty="0">
+                <a:solidFill>
+                  <a:srgbClr val="23242A"/>
+                </a:solidFill>
+                <a:latin typeface="Calibri" pitchFamily="34" charset="0"/>
+                <a:ea typeface="Calibri" pitchFamily="34" charset="-122"/>
+                <a:cs typeface="Calibri" pitchFamily="34" charset="-120"/>
+              </a:rPr>
+              <a:t>✓</a:t>
+            </a:r>
+            <a:endParaRPr lang="en-US" sz="1224" dirty="0"/>
+          </a:p>
+        </p:txBody>
+      </p:sp>
+      <p:sp>
+        <p:nvSpPr>
+          <p:cNvPr id="6" name="Text 3"/>
+          <p:cNvSpPr/>
+          <p:nvPr/>
+        </p:nvSpPr>
+        <p:spPr>
+          <a:xfrm>
             <a:off x="1115568" y="2697480"/>
             <a:ext cx="3017520" cy="384048"/>
           </a:xfrm>
@@ -2111,7 +2150,7 @@
       </p:sp>
       <p:sp>
         <p:nvSpPr>
-          <p:cNvPr id="6" name="Text 3"/>
+          <p:cNvPr id="7" name="Text 4"/>
           <p:cNvSpPr/>
           <p:nvPr/>
         </p:nvSpPr>
@@ -2150,14 +2189,14 @@
       </p:sp>
       <p:sp>
         <p:nvSpPr>
-          <p:cNvPr id="7" name="Shape 4"/>
-          <p:cNvSpPr/>
-          <p:nvPr/>
-        </p:nvSpPr>
-        <p:spPr>
-          <a:xfrm>
-            <a:off x="685800" y="3538728"/>
-            <a:ext cx="146304" cy="146304"/>
+          <p:cNvPr id="8" name="Shape 5"/>
+          <p:cNvSpPr/>
+          <p:nvPr/>
+        </p:nvSpPr>
+        <p:spPr>
+          <a:xfrm>
+            <a:off x="658368" y="3465576"/>
+            <a:ext cx="310896" cy="310896"/>
           </a:xfrm>
           <a:prstGeom prst="ellipse">
             <a:avLst/>
@@ -2175,7 +2214,46 @@
       </p:sp>
       <p:sp>
         <p:nvSpPr>
-          <p:cNvPr id="8" name="Text 5"/>
+          <p:cNvPr id="9" name="Text 6"/>
+          <p:cNvSpPr/>
+          <p:nvPr/>
+        </p:nvSpPr>
+        <p:spPr>
+          <a:xfrm>
+            <a:off x="658368" y="3465576"/>
+            <a:ext cx="310896" cy="310896"/>
+          </a:xfrm>
+          <a:prstGeom prst="rect">
+            <a:avLst/>
+          </a:prstGeom>
+          <a:noFill/>
+          <a:ln/>
+        </p:spPr>
+        <p:txBody>
+          <a:bodyPr wrap="square" lIns="0" tIns="0" rIns="0" bIns="0" rtlCol="0" anchor="ctr"/>
+          <a:lstStyle/>
+          <a:p>
+            <a:pPr algn="ctr" indent="0" marL="0">
+              <a:buNone/>
+            </a:pPr>
+            <a:r>
+              <a:rPr lang="en-US" sz="1224" b="1" dirty="0">
+                <a:solidFill>
+                  <a:srgbClr val="23242A"/>
+                </a:solidFill>
+                <a:latin typeface="Calibri" pitchFamily="34" charset="0"/>
+                <a:ea typeface="Calibri" pitchFamily="34" charset="-122"/>
+                <a:cs typeface="Calibri" pitchFamily="34" charset="-120"/>
+              </a:rPr>
+              <a:t>✓</a:t>
+            </a:r>
+            <a:endParaRPr lang="en-US" sz="1224" dirty="0"/>
+          </a:p>
+        </p:txBody>
+      </p:sp>
+      <p:sp>
+        <p:nvSpPr>
+          <p:cNvPr id="10" name="Text 7"/>
           <p:cNvSpPr/>
           <p:nvPr/>
         </p:nvSpPr>
@@ -2214,7 +2292,7 @@
       </p:sp>
       <p:sp>
         <p:nvSpPr>
-          <p:cNvPr id="9" name="Text 6"/>
+          <p:cNvPr id="11" name="Text 8"/>
           <p:cNvSpPr/>
           <p:nvPr/>
         </p:nvSpPr>
@@ -2253,14 +2331,14 @@
       </p:sp>
       <p:sp>
         <p:nvSpPr>
-          <p:cNvPr id="10" name="Shape 7"/>
-          <p:cNvSpPr/>
-          <p:nvPr/>
-        </p:nvSpPr>
-        <p:spPr>
-          <a:xfrm>
-            <a:off x="685800" y="4251960"/>
-            <a:ext cx="146304" cy="146304"/>
+          <p:cNvPr id="12" name="Shape 9"/>
+          <p:cNvSpPr/>
+          <p:nvPr/>
+        </p:nvSpPr>
+        <p:spPr>
+          <a:xfrm>
+            <a:off x="658368" y="4178808"/>
+            <a:ext cx="310896" cy="310896"/>
           </a:xfrm>
           <a:prstGeom prst="ellipse">
             <a:avLst/>
@@ -2278,7 +2356,46 @@
       </p:sp>
       <p:sp>
         <p:nvSpPr>
-          <p:cNvPr id="11" name="Text 8"/>
+          <p:cNvPr id="13" name="Text 10"/>
+          <p:cNvSpPr/>
+          <p:nvPr/>
+        </p:nvSpPr>
+        <p:spPr>
+          <a:xfrm>
+            <a:off x="658368" y="4178808"/>
+            <a:ext cx="310896" cy="310896"/>
+          </a:xfrm>
+          <a:prstGeom prst="rect">
+            <a:avLst/>
+          </a:prstGeom>
+          <a:noFill/>
+          <a:ln/>
+        </p:spPr>
+        <p:txBody>
+          <a:bodyPr wrap="square" lIns="0" tIns="0" rIns="0" bIns="0" rtlCol="0" anchor="ctr"/>
+          <a:lstStyle/>
+          <a:p>
+            <a:pPr algn="ctr" indent="0" marL="0">
+              <a:buNone/>
+            </a:pPr>
+            <a:r>
+              <a:rPr lang="en-US" sz="1224" b="1" dirty="0">
+                <a:solidFill>
+                  <a:srgbClr val="23242A"/>
+                </a:solidFill>
+                <a:latin typeface="Calibri" pitchFamily="34" charset="0"/>
+                <a:ea typeface="Calibri" pitchFamily="34" charset="-122"/>
+                <a:cs typeface="Calibri" pitchFamily="34" charset="-120"/>
+              </a:rPr>
+              <a:t>✓</a:t>
+            </a:r>
+            <a:endParaRPr lang="en-US" sz="1224" dirty="0"/>
+          </a:p>
+        </p:txBody>
+      </p:sp>
+      <p:sp>
+        <p:nvSpPr>
+          <p:cNvPr id="14" name="Text 11"/>
           <p:cNvSpPr/>
           <p:nvPr/>
         </p:nvSpPr>
@@ -2317,7 +2434,7 @@
       </p:sp>
       <p:sp>
         <p:nvSpPr>
-          <p:cNvPr id="12" name="Text 9"/>
+          <p:cNvPr id="15" name="Text 12"/>
           <p:cNvSpPr/>
           <p:nvPr/>
         </p:nvSpPr>
@@ -2356,7 +2473,7 @@
       </p:sp>
       <p:sp>
         <p:nvSpPr>
-          <p:cNvPr id="13" name="Text 10"/>
+          <p:cNvPr id="16" name="Text 13"/>
           <p:cNvSpPr/>
           <p:nvPr/>
         </p:nvSpPr>
@@ -2395,7 +2512,7 @@
       </p:sp>
       <p:sp>
         <p:nvSpPr>
-          <p:cNvPr id="14" name="Text 11"/>
+          <p:cNvPr id="17" name="Text 14"/>
           <p:cNvSpPr/>
           <p:nvPr/>
         </p:nvSpPr>
@@ -2434,7 +2551,7 @@
       </p:sp>
       <p:sp>
         <p:nvSpPr>
-          <p:cNvPr id="15" name="Shape 12"/>
+          <p:cNvPr id="18" name="Shape 15"/>
           <p:cNvSpPr/>
           <p:nvPr/>
         </p:nvSpPr>
@@ -2461,7 +2578,7 @@
       </p:sp>
       <p:pic>
         <p:nvPicPr>
-          <p:cNvPr id="16" name="Image 1" descr="preencoded.png">    </p:cNvPr>
+          <p:cNvPr id="19" name="Image 1" descr="preencoded.png">    </p:cNvPr>
           <p:cNvPicPr>
             <a:picLocks noChangeAspect="1"/>
           </p:cNvPicPr>
@@ -8902,18 +9019,18 @@
         </p:nvSpPr>
         <p:spPr>
           <a:xfrm>
-            <a:off x="822960" y="1828800"/>
-            <a:ext cx="146304" cy="146304"/>
+            <a:off x="777240" y="1764792"/>
+            <a:ext cx="384048" cy="384048"/>
           </a:xfrm>
           <a:prstGeom prst="ellipse">
             <a:avLst/>
           </a:prstGeom>
           <a:solidFill>
-            <a:srgbClr val="2E7D32"/>
+            <a:srgbClr val="E5F2E6"/>
           </a:solidFill>
           <a:ln w="12700">
             <a:solidFill>
-              <a:srgbClr val="2E7D32"/>
+              <a:srgbClr val="E5F2E6"/>
             </a:solidFill>
             <a:prstDash val="solid"/>
           </a:ln>
@@ -8927,8 +9044,47 @@
         </p:nvSpPr>
         <p:spPr>
           <a:xfrm>
-            <a:off x="1115568" y="1728216"/>
-            <a:ext cx="4663440" cy="274320"/>
+            <a:off x="777240" y="1764792"/>
+            <a:ext cx="384048" cy="384048"/>
+          </a:xfrm>
+          <a:prstGeom prst="rect">
+            <a:avLst/>
+          </a:prstGeom>
+          <a:noFill/>
+          <a:ln/>
+        </p:spPr>
+        <p:txBody>
+          <a:bodyPr wrap="square" lIns="0" tIns="0" rIns="0" bIns="0" rtlCol="0" anchor="ctr"/>
+          <a:lstStyle/>
+          <a:p>
+            <a:pPr algn="ctr" indent="0" marL="0">
+              <a:buNone/>
+            </a:pPr>
+            <a:r>
+              <a:rPr lang="en-US" sz="1512" b="1" dirty="0">
+                <a:solidFill>
+                  <a:srgbClr val="2E7D32"/>
+                </a:solidFill>
+                <a:latin typeface="Calibri" pitchFamily="34" charset="0"/>
+                <a:ea typeface="Calibri" pitchFamily="34" charset="-122"/>
+                <a:cs typeface="Calibri" pitchFamily="34" charset="-120"/>
+              </a:rPr>
+              <a:t>✓</a:t>
+            </a:r>
+            <a:endParaRPr lang="en-US" sz="1512" dirty="0"/>
+          </a:p>
+        </p:txBody>
+      </p:sp>
+      <p:sp>
+        <p:nvSpPr>
+          <p:cNvPr id="8" name="Text 5"/>
+          <p:cNvSpPr/>
+          <p:nvPr/>
+        </p:nvSpPr>
+        <p:spPr>
+          <a:xfrm>
+            <a:off x="1298448" y="1728216"/>
+            <a:ext cx="4480560" cy="274320"/>
           </a:xfrm>
           <a:prstGeom prst="rect">
             <a:avLst/>
@@ -8960,14 +9116,14 @@
       </p:sp>
       <p:sp>
         <p:nvSpPr>
-          <p:cNvPr id="8" name="Text 5"/>
-          <p:cNvSpPr/>
-          <p:nvPr/>
-        </p:nvSpPr>
-        <p:spPr>
-          <a:xfrm>
-            <a:off x="1115568" y="2029968"/>
-            <a:ext cx="4663440" cy="658368"/>
+          <p:cNvPr id="9" name="Text 6"/>
+          <p:cNvSpPr/>
+          <p:nvPr/>
+        </p:nvSpPr>
+        <p:spPr>
+          <a:xfrm>
+            <a:off x="1298448" y="2029968"/>
+            <a:ext cx="4480560" cy="658368"/>
           </a:xfrm>
           <a:prstGeom prst="rect">
             <a:avLst/>
@@ -9002,7 +9158,7 @@
       </p:sp>
       <p:sp>
         <p:nvSpPr>
-          <p:cNvPr id="9" name="Shape 6"/>
+          <p:cNvPr id="10" name="Shape 7"/>
           <p:cNvSpPr/>
           <p:nvPr/>
         </p:nvSpPr>
@@ -9029,24 +9185,24 @@
       </p:sp>
       <p:sp>
         <p:nvSpPr>
-          <p:cNvPr id="10" name="Shape 7"/>
-          <p:cNvSpPr/>
-          <p:nvPr/>
-        </p:nvSpPr>
-        <p:spPr>
-          <a:xfrm>
-            <a:off x="6492240" y="1828800"/>
-            <a:ext cx="146304" cy="146304"/>
+          <p:cNvPr id="11" name="Shape 8"/>
+          <p:cNvSpPr/>
+          <p:nvPr/>
+        </p:nvSpPr>
+        <p:spPr>
+          <a:xfrm>
+            <a:off x="6446520" y="1764792"/>
+            <a:ext cx="384048" cy="384048"/>
           </a:xfrm>
           <a:prstGeom prst="ellipse">
             <a:avLst/>
           </a:prstGeom>
           <a:solidFill>
-            <a:srgbClr val="2E7D32"/>
+            <a:srgbClr val="E5F2E6"/>
           </a:solidFill>
           <a:ln w="12700">
             <a:solidFill>
-              <a:srgbClr val="2E7D32"/>
+              <a:srgbClr val="E5F2E6"/>
             </a:solidFill>
             <a:prstDash val="solid"/>
           </a:ln>
@@ -9054,14 +9210,53 @@
       </p:sp>
       <p:sp>
         <p:nvSpPr>
-          <p:cNvPr id="11" name="Text 8"/>
-          <p:cNvSpPr/>
-          <p:nvPr/>
-        </p:nvSpPr>
-        <p:spPr>
-          <a:xfrm>
-            <a:off x="6784848" y="1728216"/>
-            <a:ext cx="4663440" cy="274320"/>
+          <p:cNvPr id="12" name="Text 9"/>
+          <p:cNvSpPr/>
+          <p:nvPr/>
+        </p:nvSpPr>
+        <p:spPr>
+          <a:xfrm>
+            <a:off x="6446520" y="1764792"/>
+            <a:ext cx="384048" cy="384048"/>
+          </a:xfrm>
+          <a:prstGeom prst="rect">
+            <a:avLst/>
+          </a:prstGeom>
+          <a:noFill/>
+          <a:ln/>
+        </p:spPr>
+        <p:txBody>
+          <a:bodyPr wrap="square" lIns="0" tIns="0" rIns="0" bIns="0" rtlCol="0" anchor="ctr"/>
+          <a:lstStyle/>
+          <a:p>
+            <a:pPr algn="ctr" indent="0" marL="0">
+              <a:buNone/>
+            </a:pPr>
+            <a:r>
+              <a:rPr lang="en-US" sz="1512" b="1" dirty="0">
+                <a:solidFill>
+                  <a:srgbClr val="2E7D32"/>
+                </a:solidFill>
+                <a:latin typeface="Calibri" pitchFamily="34" charset="0"/>
+                <a:ea typeface="Calibri" pitchFamily="34" charset="-122"/>
+                <a:cs typeface="Calibri" pitchFamily="34" charset="-120"/>
+              </a:rPr>
+              <a:t>✓</a:t>
+            </a:r>
+            <a:endParaRPr lang="en-US" sz="1512" dirty="0"/>
+          </a:p>
+        </p:txBody>
+      </p:sp>
+      <p:sp>
+        <p:nvSpPr>
+          <p:cNvPr id="13" name="Text 10"/>
+          <p:cNvSpPr/>
+          <p:nvPr/>
+        </p:nvSpPr>
+        <p:spPr>
+          <a:xfrm>
+            <a:off x="6967728" y="1728216"/>
+            <a:ext cx="4480560" cy="274320"/>
           </a:xfrm>
           <a:prstGeom prst="rect">
             <a:avLst/>
@@ -9093,14 +9288,14 @@
       </p:sp>
       <p:sp>
         <p:nvSpPr>
-          <p:cNvPr id="12" name="Text 9"/>
-          <p:cNvSpPr/>
-          <p:nvPr/>
-        </p:nvSpPr>
-        <p:spPr>
-          <a:xfrm>
-            <a:off x="6784848" y="2029968"/>
-            <a:ext cx="4663440" cy="658368"/>
+          <p:cNvPr id="14" name="Text 11"/>
+          <p:cNvSpPr/>
+          <p:nvPr/>
+        </p:nvSpPr>
+        <p:spPr>
+          <a:xfrm>
+            <a:off x="6967728" y="2029968"/>
+            <a:ext cx="4480560" cy="658368"/>
           </a:xfrm>
           <a:prstGeom prst="rect">
             <a:avLst/>
@@ -9135,7 +9330,7 @@
       </p:sp>
       <p:sp>
         <p:nvSpPr>
-          <p:cNvPr id="13" name="Shape 10"/>
+          <p:cNvPr id="15" name="Shape 12"/>
           <p:cNvSpPr/>
           <p:nvPr/>
         </p:nvSpPr>
@@ -9162,24 +9357,24 @@
       </p:sp>
       <p:sp>
         <p:nvSpPr>
-          <p:cNvPr id="14" name="Shape 11"/>
-          <p:cNvSpPr/>
-          <p:nvPr/>
-        </p:nvSpPr>
-        <p:spPr>
-          <a:xfrm>
-            <a:off x="822960" y="3310128"/>
-            <a:ext cx="146304" cy="146304"/>
+          <p:cNvPr id="16" name="Shape 13"/>
+          <p:cNvSpPr/>
+          <p:nvPr/>
+        </p:nvSpPr>
+        <p:spPr>
+          <a:xfrm>
+            <a:off x="777240" y="3246120"/>
+            <a:ext cx="384048" cy="384048"/>
           </a:xfrm>
           <a:prstGeom prst="ellipse">
             <a:avLst/>
           </a:prstGeom>
           <a:solidFill>
-            <a:srgbClr val="2E7D32"/>
+            <a:srgbClr val="E5F2E6"/>
           </a:solidFill>
           <a:ln w="12700">
             <a:solidFill>
-              <a:srgbClr val="2E7D32"/>
+              <a:srgbClr val="E5F2E6"/>
             </a:solidFill>
             <a:prstDash val="solid"/>
           </a:ln>
@@ -9187,14 +9382,53 @@
       </p:sp>
       <p:sp>
         <p:nvSpPr>
-          <p:cNvPr id="15" name="Text 12"/>
-          <p:cNvSpPr/>
-          <p:nvPr/>
-        </p:nvSpPr>
-        <p:spPr>
-          <a:xfrm>
-            <a:off x="1115568" y="3209544"/>
-            <a:ext cx="4663440" cy="274320"/>
+          <p:cNvPr id="17" name="Text 14"/>
+          <p:cNvSpPr/>
+          <p:nvPr/>
+        </p:nvSpPr>
+        <p:spPr>
+          <a:xfrm>
+            <a:off x="777240" y="3246120"/>
+            <a:ext cx="384048" cy="384048"/>
+          </a:xfrm>
+          <a:prstGeom prst="rect">
+            <a:avLst/>
+          </a:prstGeom>
+          <a:noFill/>
+          <a:ln/>
+        </p:spPr>
+        <p:txBody>
+          <a:bodyPr wrap="square" lIns="0" tIns="0" rIns="0" bIns="0" rtlCol="0" anchor="ctr"/>
+          <a:lstStyle/>
+          <a:p>
+            <a:pPr algn="ctr" indent="0" marL="0">
+              <a:buNone/>
+            </a:pPr>
+            <a:r>
+              <a:rPr lang="en-US" sz="1512" b="1" dirty="0">
+                <a:solidFill>
+                  <a:srgbClr val="2E7D32"/>
+                </a:solidFill>
+                <a:latin typeface="Calibri" pitchFamily="34" charset="0"/>
+                <a:ea typeface="Calibri" pitchFamily="34" charset="-122"/>
+                <a:cs typeface="Calibri" pitchFamily="34" charset="-120"/>
+              </a:rPr>
+              <a:t>✓</a:t>
+            </a:r>
+            <a:endParaRPr lang="en-US" sz="1512" dirty="0"/>
+          </a:p>
+        </p:txBody>
+      </p:sp>
+      <p:sp>
+        <p:nvSpPr>
+          <p:cNvPr id="18" name="Text 15"/>
+          <p:cNvSpPr/>
+          <p:nvPr/>
+        </p:nvSpPr>
+        <p:spPr>
+          <a:xfrm>
+            <a:off x="1298448" y="3209544"/>
+            <a:ext cx="4480560" cy="274320"/>
           </a:xfrm>
           <a:prstGeom prst="rect">
             <a:avLst/>
@@ -9226,14 +9460,14 @@
       </p:sp>
       <p:sp>
         <p:nvSpPr>
-          <p:cNvPr id="16" name="Text 13"/>
-          <p:cNvSpPr/>
-          <p:nvPr/>
-        </p:nvSpPr>
-        <p:spPr>
-          <a:xfrm>
-            <a:off x="1115568" y="3511296"/>
-            <a:ext cx="4663440" cy="658368"/>
+          <p:cNvPr id="19" name="Text 16"/>
+          <p:cNvSpPr/>
+          <p:nvPr/>
+        </p:nvSpPr>
+        <p:spPr>
+          <a:xfrm>
+            <a:off x="1298448" y="3511296"/>
+            <a:ext cx="4480560" cy="658368"/>
           </a:xfrm>
           <a:prstGeom prst="rect">
             <a:avLst/>
@@ -9268,7 +9502,7 @@
       </p:sp>
       <p:sp>
         <p:nvSpPr>
-          <p:cNvPr id="17" name="Shape 14"/>
+          <p:cNvPr id="20" name="Shape 17"/>
           <p:cNvSpPr/>
           <p:nvPr/>
         </p:nvSpPr>
@@ -9295,24 +9529,24 @@
       </p:sp>
       <p:sp>
         <p:nvSpPr>
-          <p:cNvPr id="18" name="Shape 15"/>
-          <p:cNvSpPr/>
-          <p:nvPr/>
-        </p:nvSpPr>
-        <p:spPr>
-          <a:xfrm>
-            <a:off x="6492240" y="3310128"/>
-            <a:ext cx="146304" cy="146304"/>
+          <p:cNvPr id="21" name="Shape 18"/>
+          <p:cNvSpPr/>
+          <p:nvPr/>
+        </p:nvSpPr>
+        <p:spPr>
+          <a:xfrm>
+            <a:off x="6446520" y="3246120"/>
+            <a:ext cx="384048" cy="384048"/>
           </a:xfrm>
           <a:prstGeom prst="ellipse">
             <a:avLst/>
           </a:prstGeom>
           <a:solidFill>
-            <a:srgbClr val="2E7D32"/>
+            <a:srgbClr val="E5F2E6"/>
           </a:solidFill>
           <a:ln w="12700">
             <a:solidFill>
-              <a:srgbClr val="2E7D32"/>
+              <a:srgbClr val="E5F2E6"/>
             </a:solidFill>
             <a:prstDash val="solid"/>
           </a:ln>
@@ -9320,14 +9554,53 @@
       </p:sp>
       <p:sp>
         <p:nvSpPr>
-          <p:cNvPr id="19" name="Text 16"/>
-          <p:cNvSpPr/>
-          <p:nvPr/>
-        </p:nvSpPr>
-        <p:spPr>
-          <a:xfrm>
-            <a:off x="6784848" y="3209544"/>
-            <a:ext cx="4663440" cy="274320"/>
+          <p:cNvPr id="22" name="Text 19"/>
+          <p:cNvSpPr/>
+          <p:nvPr/>
+        </p:nvSpPr>
+        <p:spPr>
+          <a:xfrm>
+            <a:off x="6446520" y="3246120"/>
+            <a:ext cx="384048" cy="384048"/>
+          </a:xfrm>
+          <a:prstGeom prst="rect">
+            <a:avLst/>
+          </a:prstGeom>
+          <a:noFill/>
+          <a:ln/>
+        </p:spPr>
+        <p:txBody>
+          <a:bodyPr wrap="square" lIns="0" tIns="0" rIns="0" bIns="0" rtlCol="0" anchor="ctr"/>
+          <a:lstStyle/>
+          <a:p>
+            <a:pPr algn="ctr" indent="0" marL="0">
+              <a:buNone/>
+            </a:pPr>
+            <a:r>
+              <a:rPr lang="en-US" sz="1512" b="1" dirty="0">
+                <a:solidFill>
+                  <a:srgbClr val="2E7D32"/>
+                </a:solidFill>
+                <a:latin typeface="Calibri" pitchFamily="34" charset="0"/>
+                <a:ea typeface="Calibri" pitchFamily="34" charset="-122"/>
+                <a:cs typeface="Calibri" pitchFamily="34" charset="-120"/>
+              </a:rPr>
+              <a:t>✓</a:t>
+            </a:r>
+            <a:endParaRPr lang="en-US" sz="1512" dirty="0"/>
+          </a:p>
+        </p:txBody>
+      </p:sp>
+      <p:sp>
+        <p:nvSpPr>
+          <p:cNvPr id="23" name="Text 20"/>
+          <p:cNvSpPr/>
+          <p:nvPr/>
+        </p:nvSpPr>
+        <p:spPr>
+          <a:xfrm>
+            <a:off x="6967728" y="3209544"/>
+            <a:ext cx="4480560" cy="274320"/>
           </a:xfrm>
           <a:prstGeom prst="rect">
             <a:avLst/>
@@ -9359,14 +9632,14 @@
       </p:sp>
       <p:sp>
         <p:nvSpPr>
-          <p:cNvPr id="20" name="Text 17"/>
-          <p:cNvSpPr/>
-          <p:nvPr/>
-        </p:nvSpPr>
-        <p:spPr>
-          <a:xfrm>
-            <a:off x="6784848" y="3511296"/>
-            <a:ext cx="4663440" cy="658368"/>
+          <p:cNvPr id="24" name="Text 21"/>
+          <p:cNvSpPr/>
+          <p:nvPr/>
+        </p:nvSpPr>
+        <p:spPr>
+          <a:xfrm>
+            <a:off x="6967728" y="3511296"/>
+            <a:ext cx="4480560" cy="658368"/>
           </a:xfrm>
           <a:prstGeom prst="rect">
             <a:avLst/>
@@ -9401,7 +9674,7 @@
       </p:sp>
       <p:sp>
         <p:nvSpPr>
-          <p:cNvPr id="21" name="Shape 18"/>
+          <p:cNvPr id="25" name="Shape 22"/>
           <p:cNvSpPr/>
           <p:nvPr/>
         </p:nvSpPr>
@@ -9428,24 +9701,24 @@
       </p:sp>
       <p:sp>
         <p:nvSpPr>
-          <p:cNvPr id="22" name="Shape 19"/>
-          <p:cNvSpPr/>
-          <p:nvPr/>
-        </p:nvSpPr>
-        <p:spPr>
-          <a:xfrm>
-            <a:off x="822960" y="4791456"/>
-            <a:ext cx="146304" cy="146304"/>
+          <p:cNvPr id="26" name="Shape 23"/>
+          <p:cNvSpPr/>
+          <p:nvPr/>
+        </p:nvSpPr>
+        <p:spPr>
+          <a:xfrm>
+            <a:off x="777240" y="4727448"/>
+            <a:ext cx="384048" cy="384048"/>
           </a:xfrm>
           <a:prstGeom prst="ellipse">
             <a:avLst/>
           </a:prstGeom>
           <a:solidFill>
-            <a:srgbClr val="2E7D32"/>
+            <a:srgbClr val="E5F2E6"/>
           </a:solidFill>
           <a:ln w="12700">
             <a:solidFill>
-              <a:srgbClr val="2E7D32"/>
+              <a:srgbClr val="E5F2E6"/>
             </a:solidFill>
             <a:prstDash val="solid"/>
           </a:ln>
@@ -9453,14 +9726,53 @@
       </p:sp>
       <p:sp>
         <p:nvSpPr>
-          <p:cNvPr id="23" name="Text 20"/>
-          <p:cNvSpPr/>
-          <p:nvPr/>
-        </p:nvSpPr>
-        <p:spPr>
-          <a:xfrm>
-            <a:off x="1115568" y="4690872"/>
-            <a:ext cx="4663440" cy="274320"/>
+          <p:cNvPr id="27" name="Text 24"/>
+          <p:cNvSpPr/>
+          <p:nvPr/>
+        </p:nvSpPr>
+        <p:spPr>
+          <a:xfrm>
+            <a:off x="777240" y="4727448"/>
+            <a:ext cx="384048" cy="384048"/>
+          </a:xfrm>
+          <a:prstGeom prst="rect">
+            <a:avLst/>
+          </a:prstGeom>
+          <a:noFill/>
+          <a:ln/>
+        </p:spPr>
+        <p:txBody>
+          <a:bodyPr wrap="square" lIns="0" tIns="0" rIns="0" bIns="0" rtlCol="0" anchor="ctr"/>
+          <a:lstStyle/>
+          <a:p>
+            <a:pPr algn="ctr" indent="0" marL="0">
+              <a:buNone/>
+            </a:pPr>
+            <a:r>
+              <a:rPr lang="en-US" sz="1512" b="1" dirty="0">
+                <a:solidFill>
+                  <a:srgbClr val="2E7D32"/>
+                </a:solidFill>
+                <a:latin typeface="Calibri" pitchFamily="34" charset="0"/>
+                <a:ea typeface="Calibri" pitchFamily="34" charset="-122"/>
+                <a:cs typeface="Calibri" pitchFamily="34" charset="-120"/>
+              </a:rPr>
+              <a:t>✓</a:t>
+            </a:r>
+            <a:endParaRPr lang="en-US" sz="1512" dirty="0"/>
+          </a:p>
+        </p:txBody>
+      </p:sp>
+      <p:sp>
+        <p:nvSpPr>
+          <p:cNvPr id="28" name="Text 25"/>
+          <p:cNvSpPr/>
+          <p:nvPr/>
+        </p:nvSpPr>
+        <p:spPr>
+          <a:xfrm>
+            <a:off x="1298448" y="4690872"/>
+            <a:ext cx="4480560" cy="274320"/>
           </a:xfrm>
           <a:prstGeom prst="rect">
             <a:avLst/>
@@ -9492,14 +9804,14 @@
       </p:sp>
       <p:sp>
         <p:nvSpPr>
-          <p:cNvPr id="24" name="Text 21"/>
-          <p:cNvSpPr/>
-          <p:nvPr/>
-        </p:nvSpPr>
-        <p:spPr>
-          <a:xfrm>
-            <a:off x="1115568" y="4992624"/>
-            <a:ext cx="4663440" cy="658368"/>
+          <p:cNvPr id="29" name="Text 26"/>
+          <p:cNvSpPr/>
+          <p:nvPr/>
+        </p:nvSpPr>
+        <p:spPr>
+          <a:xfrm>
+            <a:off x="1298448" y="4992624"/>
+            <a:ext cx="4480560" cy="658368"/>
           </a:xfrm>
           <a:prstGeom prst="rect">
             <a:avLst/>
@@ -9534,7 +9846,7 @@
       </p:sp>
       <p:sp>
         <p:nvSpPr>
-          <p:cNvPr id="25" name="Shape 22"/>
+          <p:cNvPr id="30" name="Shape 27"/>
           <p:cNvSpPr/>
           <p:nvPr/>
         </p:nvSpPr>
@@ -9561,24 +9873,24 @@
       </p:sp>
       <p:sp>
         <p:nvSpPr>
-          <p:cNvPr id="26" name="Shape 23"/>
-          <p:cNvSpPr/>
-          <p:nvPr/>
-        </p:nvSpPr>
-        <p:spPr>
-          <a:xfrm>
-            <a:off x="6492240" y="4791456"/>
-            <a:ext cx="146304" cy="146304"/>
+          <p:cNvPr id="31" name="Shape 28"/>
+          <p:cNvSpPr/>
+          <p:nvPr/>
+        </p:nvSpPr>
+        <p:spPr>
+          <a:xfrm>
+            <a:off x="6446520" y="4727448"/>
+            <a:ext cx="384048" cy="384048"/>
           </a:xfrm>
           <a:prstGeom prst="ellipse">
             <a:avLst/>
           </a:prstGeom>
           <a:solidFill>
-            <a:srgbClr val="2E7D32"/>
+            <a:srgbClr val="E5F2E6"/>
           </a:solidFill>
           <a:ln w="12700">
             <a:solidFill>
-              <a:srgbClr val="2E7D32"/>
+              <a:srgbClr val="E5F2E6"/>
             </a:solidFill>
             <a:prstDash val="solid"/>
           </a:ln>
@@ -9586,14 +9898,53 @@
       </p:sp>
       <p:sp>
         <p:nvSpPr>
-          <p:cNvPr id="27" name="Text 24"/>
-          <p:cNvSpPr/>
-          <p:nvPr/>
-        </p:nvSpPr>
-        <p:spPr>
-          <a:xfrm>
-            <a:off x="6784848" y="4690872"/>
-            <a:ext cx="4663440" cy="274320"/>
+          <p:cNvPr id="32" name="Text 29"/>
+          <p:cNvSpPr/>
+          <p:nvPr/>
+        </p:nvSpPr>
+        <p:spPr>
+          <a:xfrm>
+            <a:off x="6446520" y="4727448"/>
+            <a:ext cx="384048" cy="384048"/>
+          </a:xfrm>
+          <a:prstGeom prst="rect">
+            <a:avLst/>
+          </a:prstGeom>
+          <a:noFill/>
+          <a:ln/>
+        </p:spPr>
+        <p:txBody>
+          <a:bodyPr wrap="square" lIns="0" tIns="0" rIns="0" bIns="0" rtlCol="0" anchor="ctr"/>
+          <a:lstStyle/>
+          <a:p>
+            <a:pPr algn="ctr" indent="0" marL="0">
+              <a:buNone/>
+            </a:pPr>
+            <a:r>
+              <a:rPr lang="en-US" sz="1512" b="1" dirty="0">
+                <a:solidFill>
+                  <a:srgbClr val="2E7D32"/>
+                </a:solidFill>
+                <a:latin typeface="Calibri" pitchFamily="34" charset="0"/>
+                <a:ea typeface="Calibri" pitchFamily="34" charset="-122"/>
+                <a:cs typeface="Calibri" pitchFamily="34" charset="-120"/>
+              </a:rPr>
+              <a:t>✓</a:t>
+            </a:r>
+            <a:endParaRPr lang="en-US" sz="1512" dirty="0"/>
+          </a:p>
+        </p:txBody>
+      </p:sp>
+      <p:sp>
+        <p:nvSpPr>
+          <p:cNvPr id="33" name="Text 30"/>
+          <p:cNvSpPr/>
+          <p:nvPr/>
+        </p:nvSpPr>
+        <p:spPr>
+          <a:xfrm>
+            <a:off x="6967728" y="4690872"/>
+            <a:ext cx="4480560" cy="274320"/>
           </a:xfrm>
           <a:prstGeom prst="rect">
             <a:avLst/>
@@ -9625,14 +9976,14 @@
       </p:sp>
       <p:sp>
         <p:nvSpPr>
-          <p:cNvPr id="28" name="Text 25"/>
-          <p:cNvSpPr/>
-          <p:nvPr/>
-        </p:nvSpPr>
-        <p:spPr>
-          <a:xfrm>
-            <a:off x="6784848" y="4992624"/>
-            <a:ext cx="4663440" cy="658368"/>
+          <p:cNvPr id="34" name="Text 31"/>
+          <p:cNvSpPr/>
+          <p:nvPr/>
+        </p:nvSpPr>
+        <p:spPr>
+          <a:xfrm>
+            <a:off x="6967728" y="4992624"/>
+            <a:ext cx="4480560" cy="658368"/>
           </a:xfrm>
           <a:prstGeom prst="rect">
             <a:avLst/>
@@ -9667,7 +10018,7 @@
       </p:sp>
       <p:sp>
         <p:nvSpPr>
-          <p:cNvPr id="29" name="Text 26"/>
+          <p:cNvPr id="35" name="Text 32"/>
           <p:cNvSpPr/>
           <p:nvPr/>
         </p:nvSpPr>
@@ -9846,18 +10197,18 @@
         </p:nvSpPr>
         <p:spPr>
           <a:xfrm>
-            <a:off x="603504" y="1636776"/>
-            <a:ext cx="146304" cy="146304"/>
+            <a:off x="566928" y="1572768"/>
+            <a:ext cx="274320" cy="274320"/>
           </a:xfrm>
           <a:prstGeom prst="ellipse">
             <a:avLst/>
           </a:prstGeom>
           <a:solidFill>
-            <a:srgbClr val="C9A227"/>
+            <a:srgbClr val="23242A"/>
           </a:solidFill>
           <a:ln w="12700">
             <a:solidFill>
-              <a:srgbClr val="C9A227"/>
+              <a:srgbClr val="23242A"/>
             </a:solidFill>
             <a:prstDash val="solid"/>
           </a:ln>
@@ -9871,6 +10222,45 @@
         </p:nvSpPr>
         <p:spPr>
           <a:xfrm>
+            <a:off x="566928" y="1572768"/>
+            <a:ext cx="274320" cy="274320"/>
+          </a:xfrm>
+          <a:prstGeom prst="rect">
+            <a:avLst/>
+          </a:prstGeom>
+          <a:noFill/>
+          <a:ln/>
+        </p:spPr>
+        <p:txBody>
+          <a:bodyPr wrap="square" lIns="0" tIns="0" rIns="0" bIns="0" rtlCol="0" anchor="ctr"/>
+          <a:lstStyle/>
+          <a:p>
+            <a:pPr algn="ctr" indent="0" marL="0">
+              <a:buNone/>
+            </a:pPr>
+            <a:r>
+              <a:rPr lang="en-US" sz="1080" b="1" dirty="0">
+                <a:solidFill>
+                  <a:srgbClr val="C9A227"/>
+                </a:solidFill>
+                <a:latin typeface="Calibri" pitchFamily="34" charset="0"/>
+                <a:ea typeface="Calibri" pitchFamily="34" charset="-122"/>
+                <a:cs typeface="Calibri" pitchFamily="34" charset="-120"/>
+              </a:rPr>
+              <a:t>✓</a:t>
+            </a:r>
+            <a:endParaRPr lang="en-US" sz="1080" dirty="0"/>
+          </a:p>
+        </p:txBody>
+      </p:sp>
+      <p:sp>
+        <p:nvSpPr>
+          <p:cNvPr id="7" name="Text 4"/>
+          <p:cNvSpPr/>
+          <p:nvPr/>
+        </p:nvSpPr>
+        <p:spPr>
+          <a:xfrm>
             <a:off x="987552" y="1463040"/>
             <a:ext cx="4206240" cy="475488"/>
           </a:xfrm>
@@ -9904,7 +10294,7 @@
       </p:sp>
       <p:sp>
         <p:nvSpPr>
-          <p:cNvPr id="7" name="Text 4"/>
+          <p:cNvPr id="8" name="Text 5"/>
           <p:cNvSpPr/>
           <p:nvPr/>
         </p:nvSpPr>
@@ -9943,24 +10333,24 @@
       </p:sp>
       <p:sp>
         <p:nvSpPr>
-          <p:cNvPr id="8" name="Shape 5"/>
-          <p:cNvSpPr/>
-          <p:nvPr/>
-        </p:nvSpPr>
-        <p:spPr>
-          <a:xfrm>
-            <a:off x="603504" y="2258568"/>
-            <a:ext cx="146304" cy="146304"/>
+          <p:cNvPr id="9" name="Shape 6"/>
+          <p:cNvSpPr/>
+          <p:nvPr/>
+        </p:nvSpPr>
+        <p:spPr>
+          <a:xfrm>
+            <a:off x="566928" y="2194560"/>
+            <a:ext cx="274320" cy="274320"/>
           </a:xfrm>
           <a:prstGeom prst="ellipse">
             <a:avLst/>
           </a:prstGeom>
           <a:solidFill>
-            <a:srgbClr val="C9A227"/>
+            <a:srgbClr val="23242A"/>
           </a:solidFill>
           <a:ln w="12700">
             <a:solidFill>
-              <a:srgbClr val="C9A227"/>
+              <a:srgbClr val="23242A"/>
             </a:solidFill>
             <a:prstDash val="solid"/>
           </a:ln>
@@ -9968,7 +10358,46 @@
       </p:sp>
       <p:sp>
         <p:nvSpPr>
-          <p:cNvPr id="9" name="Text 6"/>
+          <p:cNvPr id="10" name="Text 7"/>
+          <p:cNvSpPr/>
+          <p:nvPr/>
+        </p:nvSpPr>
+        <p:spPr>
+          <a:xfrm>
+            <a:off x="566928" y="2194560"/>
+            <a:ext cx="274320" cy="274320"/>
+          </a:xfrm>
+          <a:prstGeom prst="rect">
+            <a:avLst/>
+          </a:prstGeom>
+          <a:noFill/>
+          <a:ln/>
+        </p:spPr>
+        <p:txBody>
+          <a:bodyPr wrap="square" lIns="0" tIns="0" rIns="0" bIns="0" rtlCol="0" anchor="ctr"/>
+          <a:lstStyle/>
+          <a:p>
+            <a:pPr algn="ctr" indent="0" marL="0">
+              <a:buNone/>
+            </a:pPr>
+            <a:r>
+              <a:rPr lang="en-US" sz="1080" b="1" dirty="0">
+                <a:solidFill>
+                  <a:srgbClr val="C9A227"/>
+                </a:solidFill>
+                <a:latin typeface="Calibri" pitchFamily="34" charset="0"/>
+                <a:ea typeface="Calibri" pitchFamily="34" charset="-122"/>
+                <a:cs typeface="Calibri" pitchFamily="34" charset="-120"/>
+              </a:rPr>
+              <a:t>✓</a:t>
+            </a:r>
+            <a:endParaRPr lang="en-US" sz="1080" dirty="0"/>
+          </a:p>
+        </p:txBody>
+      </p:sp>
+      <p:sp>
+        <p:nvSpPr>
+          <p:cNvPr id="11" name="Text 8"/>
           <p:cNvSpPr/>
           <p:nvPr/>
         </p:nvSpPr>
@@ -10007,7 +10436,7 @@
       </p:sp>
       <p:sp>
         <p:nvSpPr>
-          <p:cNvPr id="10" name="Text 7"/>
+          <p:cNvPr id="12" name="Text 9"/>
           <p:cNvSpPr/>
           <p:nvPr/>
         </p:nvSpPr>
@@ -10046,24 +10475,24 @@
       </p:sp>
       <p:sp>
         <p:nvSpPr>
-          <p:cNvPr id="11" name="Shape 8"/>
-          <p:cNvSpPr/>
-          <p:nvPr/>
-        </p:nvSpPr>
-        <p:spPr>
-          <a:xfrm>
-            <a:off x="603504" y="2880360"/>
-            <a:ext cx="146304" cy="146304"/>
+          <p:cNvPr id="13" name="Shape 10"/>
+          <p:cNvSpPr/>
+          <p:nvPr/>
+        </p:nvSpPr>
+        <p:spPr>
+          <a:xfrm>
+            <a:off x="566928" y="2816352"/>
+            <a:ext cx="274320" cy="274320"/>
           </a:xfrm>
           <a:prstGeom prst="ellipse">
             <a:avLst/>
           </a:prstGeom>
           <a:solidFill>
-            <a:srgbClr val="C9A227"/>
+            <a:srgbClr val="23242A"/>
           </a:solidFill>
           <a:ln w="12700">
             <a:solidFill>
-              <a:srgbClr val="C9A227"/>
+              <a:srgbClr val="23242A"/>
             </a:solidFill>
             <a:prstDash val="solid"/>
           </a:ln>
@@ -10071,7 +10500,46 @@
       </p:sp>
       <p:sp>
         <p:nvSpPr>
-          <p:cNvPr id="12" name="Text 9"/>
+          <p:cNvPr id="14" name="Text 11"/>
+          <p:cNvSpPr/>
+          <p:nvPr/>
+        </p:nvSpPr>
+        <p:spPr>
+          <a:xfrm>
+            <a:off x="566928" y="2816352"/>
+            <a:ext cx="274320" cy="274320"/>
+          </a:xfrm>
+          <a:prstGeom prst="rect">
+            <a:avLst/>
+          </a:prstGeom>
+          <a:noFill/>
+          <a:ln/>
+        </p:spPr>
+        <p:txBody>
+          <a:bodyPr wrap="square" lIns="0" tIns="0" rIns="0" bIns="0" rtlCol="0" anchor="ctr"/>
+          <a:lstStyle/>
+          <a:p>
+            <a:pPr algn="ctr" indent="0" marL="0">
+              <a:buNone/>
+            </a:pPr>
+            <a:r>
+              <a:rPr lang="en-US" sz="1080" b="1" dirty="0">
+                <a:solidFill>
+                  <a:srgbClr val="C9A227"/>
+                </a:solidFill>
+                <a:latin typeface="Calibri" pitchFamily="34" charset="0"/>
+                <a:ea typeface="Calibri" pitchFamily="34" charset="-122"/>
+                <a:cs typeface="Calibri" pitchFamily="34" charset="-120"/>
+              </a:rPr>
+              <a:t>✓</a:t>
+            </a:r>
+            <a:endParaRPr lang="en-US" sz="1080" dirty="0"/>
+          </a:p>
+        </p:txBody>
+      </p:sp>
+      <p:sp>
+        <p:nvSpPr>
+          <p:cNvPr id="15" name="Text 12"/>
           <p:cNvSpPr/>
           <p:nvPr/>
         </p:nvSpPr>
@@ -10110,7 +10578,7 @@
       </p:sp>
       <p:sp>
         <p:nvSpPr>
-          <p:cNvPr id="13" name="Text 10"/>
+          <p:cNvPr id="16" name="Text 13"/>
           <p:cNvSpPr/>
           <p:nvPr/>
         </p:nvSpPr>
@@ -10149,24 +10617,24 @@
       </p:sp>
       <p:sp>
         <p:nvSpPr>
-          <p:cNvPr id="14" name="Shape 11"/>
-          <p:cNvSpPr/>
-          <p:nvPr/>
-        </p:nvSpPr>
-        <p:spPr>
-          <a:xfrm>
-            <a:off x="603504" y="3502152"/>
-            <a:ext cx="146304" cy="146304"/>
+          <p:cNvPr id="17" name="Shape 14"/>
+          <p:cNvSpPr/>
+          <p:nvPr/>
+        </p:nvSpPr>
+        <p:spPr>
+          <a:xfrm>
+            <a:off x="566928" y="3438144"/>
+            <a:ext cx="274320" cy="274320"/>
           </a:xfrm>
           <a:prstGeom prst="ellipse">
             <a:avLst/>
           </a:prstGeom>
           <a:solidFill>
-            <a:srgbClr val="C9A227"/>
+            <a:srgbClr val="23242A"/>
           </a:solidFill>
           <a:ln w="12700">
             <a:solidFill>
-              <a:srgbClr val="C9A227"/>
+              <a:srgbClr val="23242A"/>
             </a:solidFill>
             <a:prstDash val="solid"/>
           </a:ln>
@@ -10174,7 +10642,46 @@
       </p:sp>
       <p:sp>
         <p:nvSpPr>
-          <p:cNvPr id="15" name="Text 12"/>
+          <p:cNvPr id="18" name="Text 15"/>
+          <p:cNvSpPr/>
+          <p:nvPr/>
+        </p:nvSpPr>
+        <p:spPr>
+          <a:xfrm>
+            <a:off x="566928" y="3438144"/>
+            <a:ext cx="274320" cy="274320"/>
+          </a:xfrm>
+          <a:prstGeom prst="rect">
+            <a:avLst/>
+          </a:prstGeom>
+          <a:noFill/>
+          <a:ln/>
+        </p:spPr>
+        <p:txBody>
+          <a:bodyPr wrap="square" lIns="0" tIns="0" rIns="0" bIns="0" rtlCol="0" anchor="ctr"/>
+          <a:lstStyle/>
+          <a:p>
+            <a:pPr algn="ctr" indent="0" marL="0">
+              <a:buNone/>
+            </a:pPr>
+            <a:r>
+              <a:rPr lang="en-US" sz="1080" b="1" dirty="0">
+                <a:solidFill>
+                  <a:srgbClr val="C9A227"/>
+                </a:solidFill>
+                <a:latin typeface="Calibri" pitchFamily="34" charset="0"/>
+                <a:ea typeface="Calibri" pitchFamily="34" charset="-122"/>
+                <a:cs typeface="Calibri" pitchFamily="34" charset="-120"/>
+              </a:rPr>
+              <a:t>✓</a:t>
+            </a:r>
+            <a:endParaRPr lang="en-US" sz="1080" dirty="0"/>
+          </a:p>
+        </p:txBody>
+      </p:sp>
+      <p:sp>
+        <p:nvSpPr>
+          <p:cNvPr id="19" name="Text 16"/>
           <p:cNvSpPr/>
           <p:nvPr/>
         </p:nvSpPr>
@@ -10213,7 +10720,7 @@
       </p:sp>
       <p:sp>
         <p:nvSpPr>
-          <p:cNvPr id="16" name="Text 13"/>
+          <p:cNvPr id="20" name="Text 17"/>
           <p:cNvSpPr/>
           <p:nvPr/>
         </p:nvSpPr>
@@ -10252,24 +10759,24 @@
       </p:sp>
       <p:sp>
         <p:nvSpPr>
-          <p:cNvPr id="17" name="Shape 14"/>
-          <p:cNvSpPr/>
-          <p:nvPr/>
-        </p:nvSpPr>
-        <p:spPr>
-          <a:xfrm>
-            <a:off x="603504" y="4123944"/>
-            <a:ext cx="146304" cy="146304"/>
+          <p:cNvPr id="21" name="Shape 18"/>
+          <p:cNvSpPr/>
+          <p:nvPr/>
+        </p:nvSpPr>
+        <p:spPr>
+          <a:xfrm>
+            <a:off x="566928" y="4059936"/>
+            <a:ext cx="274320" cy="274320"/>
           </a:xfrm>
           <a:prstGeom prst="ellipse">
             <a:avLst/>
           </a:prstGeom>
           <a:solidFill>
-            <a:srgbClr val="C9A227"/>
+            <a:srgbClr val="23242A"/>
           </a:solidFill>
           <a:ln w="12700">
             <a:solidFill>
-              <a:srgbClr val="C9A227"/>
+              <a:srgbClr val="23242A"/>
             </a:solidFill>
             <a:prstDash val="solid"/>
           </a:ln>
@@ -10277,7 +10784,46 @@
       </p:sp>
       <p:sp>
         <p:nvSpPr>
-          <p:cNvPr id="18" name="Text 15"/>
+          <p:cNvPr id="22" name="Text 19"/>
+          <p:cNvSpPr/>
+          <p:nvPr/>
+        </p:nvSpPr>
+        <p:spPr>
+          <a:xfrm>
+            <a:off x="566928" y="4059936"/>
+            <a:ext cx="274320" cy="274320"/>
+          </a:xfrm>
+          <a:prstGeom prst="rect">
+            <a:avLst/>
+          </a:prstGeom>
+          <a:noFill/>
+          <a:ln/>
+        </p:spPr>
+        <p:txBody>
+          <a:bodyPr wrap="square" lIns="0" tIns="0" rIns="0" bIns="0" rtlCol="0" anchor="ctr"/>
+          <a:lstStyle/>
+          <a:p>
+            <a:pPr algn="ctr" indent="0" marL="0">
+              <a:buNone/>
+            </a:pPr>
+            <a:r>
+              <a:rPr lang="en-US" sz="1080" b="1" dirty="0">
+                <a:solidFill>
+                  <a:srgbClr val="C9A227"/>
+                </a:solidFill>
+                <a:latin typeface="Calibri" pitchFamily="34" charset="0"/>
+                <a:ea typeface="Calibri" pitchFamily="34" charset="-122"/>
+                <a:cs typeface="Calibri" pitchFamily="34" charset="-120"/>
+              </a:rPr>
+              <a:t>✓</a:t>
+            </a:r>
+            <a:endParaRPr lang="en-US" sz="1080" dirty="0"/>
+          </a:p>
+        </p:txBody>
+      </p:sp>
+      <p:sp>
+        <p:nvSpPr>
+          <p:cNvPr id="23" name="Text 20"/>
           <p:cNvSpPr/>
           <p:nvPr/>
         </p:nvSpPr>
@@ -10316,7 +10862,7 @@
       </p:sp>
       <p:sp>
         <p:nvSpPr>
-          <p:cNvPr id="19" name="Text 16"/>
+          <p:cNvPr id="24" name="Text 21"/>
           <p:cNvSpPr/>
           <p:nvPr/>
         </p:nvSpPr>
@@ -10355,24 +10901,24 @@
       </p:sp>
       <p:sp>
         <p:nvSpPr>
-          <p:cNvPr id="20" name="Shape 17"/>
-          <p:cNvSpPr/>
-          <p:nvPr/>
-        </p:nvSpPr>
-        <p:spPr>
-          <a:xfrm>
-            <a:off x="603504" y="4745736"/>
-            <a:ext cx="146304" cy="146304"/>
+          <p:cNvPr id="25" name="Shape 22"/>
+          <p:cNvSpPr/>
+          <p:nvPr/>
+        </p:nvSpPr>
+        <p:spPr>
+          <a:xfrm>
+            <a:off x="566928" y="4681728"/>
+            <a:ext cx="274320" cy="274320"/>
           </a:xfrm>
           <a:prstGeom prst="ellipse">
             <a:avLst/>
           </a:prstGeom>
           <a:solidFill>
-            <a:srgbClr val="C9A227"/>
+            <a:srgbClr val="23242A"/>
           </a:solidFill>
           <a:ln w="12700">
             <a:solidFill>
-              <a:srgbClr val="C9A227"/>
+              <a:srgbClr val="23242A"/>
             </a:solidFill>
             <a:prstDash val="solid"/>
           </a:ln>
@@ -10380,7 +10926,46 @@
       </p:sp>
       <p:sp>
         <p:nvSpPr>
-          <p:cNvPr id="21" name="Text 18"/>
+          <p:cNvPr id="26" name="Text 23"/>
+          <p:cNvSpPr/>
+          <p:nvPr/>
+        </p:nvSpPr>
+        <p:spPr>
+          <a:xfrm>
+            <a:off x="566928" y="4681728"/>
+            <a:ext cx="274320" cy="274320"/>
+          </a:xfrm>
+          <a:prstGeom prst="rect">
+            <a:avLst/>
+          </a:prstGeom>
+          <a:noFill/>
+          <a:ln/>
+        </p:spPr>
+        <p:txBody>
+          <a:bodyPr wrap="square" lIns="0" tIns="0" rIns="0" bIns="0" rtlCol="0" anchor="ctr"/>
+          <a:lstStyle/>
+          <a:p>
+            <a:pPr algn="ctr" indent="0" marL="0">
+              <a:buNone/>
+            </a:pPr>
+            <a:r>
+              <a:rPr lang="en-US" sz="1080" b="1" dirty="0">
+                <a:solidFill>
+                  <a:srgbClr val="C9A227"/>
+                </a:solidFill>
+                <a:latin typeface="Calibri" pitchFamily="34" charset="0"/>
+                <a:ea typeface="Calibri" pitchFamily="34" charset="-122"/>
+                <a:cs typeface="Calibri" pitchFamily="34" charset="-120"/>
+              </a:rPr>
+              <a:t>✓</a:t>
+            </a:r>
+            <a:endParaRPr lang="en-US" sz="1080" dirty="0"/>
+          </a:p>
+        </p:txBody>
+      </p:sp>
+      <p:sp>
+        <p:nvSpPr>
+          <p:cNvPr id="27" name="Text 24"/>
           <p:cNvSpPr/>
           <p:nvPr/>
         </p:nvSpPr>
@@ -10419,7 +11004,7 @@
       </p:sp>
       <p:sp>
         <p:nvSpPr>
-          <p:cNvPr id="22" name="Text 19"/>
+          <p:cNvPr id="28" name="Text 25"/>
           <p:cNvSpPr/>
           <p:nvPr/>
         </p:nvSpPr>
@@ -10458,7 +11043,7 @@
       </p:sp>
       <p:sp>
         <p:nvSpPr>
-          <p:cNvPr id="23" name="Shape 20"/>
+          <p:cNvPr id="29" name="Shape 26"/>
           <p:cNvSpPr/>
           <p:nvPr/>
         </p:nvSpPr>
@@ -10485,7 +11070,7 @@
       </p:sp>
       <p:sp>
         <p:nvSpPr>
-          <p:cNvPr id="24" name="Text 21"/>
+          <p:cNvPr id="30" name="Text 27"/>
           <p:cNvSpPr/>
           <p:nvPr/>
         </p:nvSpPr>
@@ -10524,7 +11109,7 @@
       </p:sp>
       <p:sp>
         <p:nvSpPr>
-          <p:cNvPr id="25" name="Text 22"/>
+          <p:cNvPr id="31" name="Text 28"/>
           <p:cNvSpPr/>
           <p:nvPr/>
         </p:nvSpPr>

</xml_diff>